<commit_message>
Restore third PPT design (notebook knowledge slides v3)
Revert to commit 62a3426 style: bordered layout, cream notebook
pages with red margin, 含课堂笔记 · 2026版, per-lesson color themes.
Keep only 5 files: lessons 21-24 + showcase.

Co-authored-by: Lin Silentium <decemberlin54-del@users.noreply.github.com>
</commit_message>
<xml_diff>
--- a/unit6-lesson23-nuwa.pptx
+++ b/unit6-lesson23-nuwa.pptx
@@ -3304,8 +3304,8 @@
         </p:nvSpPr>
         <p:spPr>
           <a:xfrm>
-            <a:off x="1371600" y="2011680"/>
-            <a:ext cx="9418320" cy="1645920"/>
+            <a:off x="1371600" y="1828800"/>
+            <a:ext cx="9418320" cy="1828800"/>
           </a:xfrm>
           <a:prstGeom prst="rect">
             <a:avLst/>
@@ -3347,6 +3347,22 @@
                 <a:latin typeface="Microsoft YaHei"/>
               </a:rPr>
               <a:t>第23课 · 第六、七课时 · 创造与生命</a:t>
+            </a:r>
+          </a:p>
+          <a:p>
+            <a:pPr algn="ctr">
+              <a:spcAft>
+                <a:spcPts val="1000"/>
+              </a:spcAft>
+            </a:pPr>
+            <a:r>
+              <a:rPr sz="2000" b="1">
+                <a:solidFill>
+                  <a:srgbClr val="A0C896"/>
+                </a:solidFill>
+                <a:latin typeface="Microsoft YaHei"/>
+              </a:rPr>
+              <a:t>含课堂笔记 · 2026版</a:t>
             </a:r>
           </a:p>
         </p:txBody>
@@ -3535,8 +3551,342 @@
         </p:nvSpPr>
         <p:spPr>
           <a:xfrm>
-            <a:off x="4953304" y="502920"/>
-            <a:ext cx="2286000" cy="411480"/>
+            <a:off x="502920" y="384048"/>
+            <a:ext cx="2011680" cy="384048"/>
+          </a:xfrm>
+          <a:prstGeom prst="roundRect">
+            <a:avLst/>
+          </a:prstGeom>
+          <a:solidFill>
+            <a:srgbClr val="468250"/>
+          </a:solidFill>
+          <a:ln>
+            <a:noFill/>
+          </a:ln>
+        </p:spPr>
+        <p:style>
+          <a:lnRef idx="1">
+            <a:schemeClr val="accent1"/>
+          </a:lnRef>
+          <a:fillRef idx="3">
+            <a:schemeClr val="accent1"/>
+          </a:fillRef>
+          <a:effectRef idx="2">
+            <a:schemeClr val="accent1"/>
+          </a:effectRef>
+          <a:fontRef idx="minor">
+            <a:schemeClr val="lt1"/>
+          </a:fontRef>
+        </p:style>
+        <p:txBody>
+          <a:bodyPr rtlCol="0" anchor="ctr"/>
+          <a:lstStyle/>
+          <a:p>
+            <a:pPr algn="ctr"/>
+          </a:p>
+        </p:txBody>
+      </p:sp>
+      <p:sp>
+        <p:nvSpPr>
+          <p:cNvPr id="7" name="TextBox 6"/>
+          <p:cNvSpPr txBox="1"/>
+          <p:nvPr/>
+        </p:nvSpPr>
+        <p:spPr>
+          <a:xfrm>
+            <a:off x="502920" y="402336"/>
+            <a:ext cx="2011680" cy="347472"/>
+          </a:xfrm>
+          <a:prstGeom prst="rect">
+            <a:avLst/>
+          </a:prstGeom>
+          <a:noFill/>
+        </p:spPr>
+        <p:txBody>
+          <a:bodyPr wrap="none">
+            <a:spAutoFit/>
+          </a:bodyPr>
+          <a:lstStyle/>
+          <a:p>
+            <a:pPr algn="ctr">
+              <a:spcAft>
+                <a:spcPts val="1000"/>
+              </a:spcAft>
+            </a:pPr>
+            <a:r>
+              <a:rPr sz="1600" b="1">
+                <a:solidFill>
+                  <a:srgbClr val="FFFFFF"/>
+                </a:solidFill>
+                <a:latin typeface="Microsoft YaHei"/>
+              </a:rPr>
+              <a:t>知识要点</a:t>
+            </a:r>
+          </a:p>
+        </p:txBody>
+      </p:sp>
+      <p:sp>
+        <p:nvSpPr>
+          <p:cNvPr id="8" name="TextBox 7"/>
+          <p:cNvSpPr txBox="1"/>
+          <p:nvPr/>
+        </p:nvSpPr>
+        <p:spPr>
+          <a:xfrm>
+            <a:off x="1371600" y="384048"/>
+            <a:ext cx="9418320" cy="822960"/>
+          </a:xfrm>
+          <a:prstGeom prst="rect">
+            <a:avLst/>
+          </a:prstGeom>
+          <a:noFill/>
+        </p:spPr>
+        <p:txBody>
+          <a:bodyPr wrap="square">
+            <a:spAutoFit/>
+          </a:bodyPr>
+          <a:lstStyle/>
+          <a:p>
+            <a:pPr algn="ctr">
+              <a:spcAft>
+                <a:spcPts val="1000"/>
+              </a:spcAft>
+            </a:pPr>
+            <a:r>
+              <a:rPr sz="3400" b="1">
+                <a:solidFill>
+                  <a:srgbClr val="468250"/>
+                </a:solidFill>
+                <a:latin typeface="Microsoft YaHei"/>
+              </a:rPr>
+              <a:t>文学常识</a:t>
+            </a:r>
+          </a:p>
+        </p:txBody>
+      </p:sp>
+      <p:sp>
+        <p:nvSpPr>
+          <p:cNvPr id="9" name="Rounded Rectangle 8"/>
+          <p:cNvSpPr/>
+          <p:nvPr/>
+        </p:nvSpPr>
+        <p:spPr>
+          <a:xfrm>
+            <a:off x="1067104" y="1143000"/>
+            <a:ext cx="10058400" cy="3721608"/>
+          </a:xfrm>
+          <a:prstGeom prst="roundRect">
+            <a:avLst/>
+          </a:prstGeom>
+          <a:solidFill>
+            <a:srgbClr val="FFFCEB"/>
+          </a:solidFill>
+          <a:ln w="25400">
+            <a:solidFill>
+              <a:srgbClr val="5A8C5A"/>
+            </a:solidFill>
+          </a:ln>
+        </p:spPr>
+        <p:style>
+          <a:lnRef idx="1">
+            <a:schemeClr val="accent1"/>
+          </a:lnRef>
+          <a:fillRef idx="3">
+            <a:schemeClr val="accent1"/>
+          </a:fillRef>
+          <a:effectRef idx="2">
+            <a:schemeClr val="accent1"/>
+          </a:effectRef>
+          <a:fontRef idx="minor">
+            <a:schemeClr val="lt1"/>
+          </a:fontRef>
+        </p:style>
+        <p:txBody>
+          <a:bodyPr rtlCol="0" anchor="ctr"/>
+          <a:lstStyle/>
+          <a:p>
+            <a:pPr algn="ctr"/>
+          </a:p>
+        </p:txBody>
+      </p:sp>
+      <p:sp>
+        <p:nvSpPr>
+          <p:cNvPr id="10" name="Rectangle 9"/>
+          <p:cNvSpPr/>
+          <p:nvPr/>
+        </p:nvSpPr>
+        <p:spPr>
+          <a:xfrm>
+            <a:off x="1067104" y="1143000"/>
+            <a:ext cx="10058400" cy="384048"/>
+          </a:xfrm>
+          <a:prstGeom prst="rect">
+            <a:avLst/>
+          </a:prstGeom>
+          <a:solidFill>
+            <a:srgbClr val="468250"/>
+          </a:solidFill>
+          <a:ln>
+            <a:noFill/>
+          </a:ln>
+        </p:spPr>
+        <p:style>
+          <a:lnRef idx="1">
+            <a:schemeClr val="accent1"/>
+          </a:lnRef>
+          <a:fillRef idx="3">
+            <a:schemeClr val="accent1"/>
+          </a:fillRef>
+          <a:effectRef idx="2">
+            <a:schemeClr val="accent1"/>
+          </a:effectRef>
+          <a:fontRef idx="minor">
+            <a:schemeClr val="lt1"/>
+          </a:fontRef>
+        </p:style>
+        <p:txBody>
+          <a:bodyPr rtlCol="0" anchor="ctr"/>
+          <a:lstStyle/>
+          <a:p>
+            <a:pPr algn="ctr"/>
+          </a:p>
+        </p:txBody>
+      </p:sp>
+      <p:sp>
+        <p:nvSpPr>
+          <p:cNvPr id="11" name="TextBox 10"/>
+          <p:cNvSpPr txBox="1"/>
+          <p:nvPr/>
+        </p:nvSpPr>
+        <p:spPr>
+          <a:xfrm>
+            <a:off x="1067104" y="1179576"/>
+            <a:ext cx="10058400" cy="347472"/>
+          </a:xfrm>
+          <a:prstGeom prst="rect">
+            <a:avLst/>
+          </a:prstGeom>
+          <a:noFill/>
+        </p:spPr>
+        <p:txBody>
+          <a:bodyPr wrap="none">
+            <a:spAutoFit/>
+          </a:bodyPr>
+          <a:lstStyle/>
+          <a:p>
+            <a:pPr algn="ctr">
+              <a:spcAft>
+                <a:spcPts val="1000"/>
+              </a:spcAft>
+            </a:pPr>
+            <a:r>
+              <a:rPr sz="1800" b="1">
+                <a:solidFill>
+                  <a:srgbClr val="FFFFFF"/>
+                </a:solidFill>
+                <a:latin typeface="Microsoft YaHei"/>
+              </a:rPr>
+              <a:t>📝  课堂笔记  —  请摘抄要点</a:t>
+            </a:r>
+          </a:p>
+        </p:txBody>
+      </p:sp>
+      <p:sp>
+        <p:nvSpPr>
+          <p:cNvPr id="12" name="Rectangle 11"/>
+          <p:cNvSpPr/>
+          <p:nvPr/>
+        </p:nvSpPr>
+        <p:spPr>
+          <a:xfrm>
+            <a:off x="1570024" y="1527048"/>
+            <a:ext cx="27432" cy="3337560"/>
+          </a:xfrm>
+          <a:prstGeom prst="rect">
+            <a:avLst/>
+          </a:prstGeom>
+          <a:solidFill>
+            <a:srgbClr val="DC5050"/>
+          </a:solidFill>
+          <a:ln>
+            <a:noFill/>
+          </a:ln>
+        </p:spPr>
+        <p:style>
+          <a:lnRef idx="1">
+            <a:schemeClr val="accent1"/>
+          </a:lnRef>
+          <a:fillRef idx="3">
+            <a:schemeClr val="accent1"/>
+          </a:fillRef>
+          <a:effectRef idx="2">
+            <a:schemeClr val="accent1"/>
+          </a:effectRef>
+          <a:fontRef idx="minor">
+            <a:schemeClr val="lt1"/>
+          </a:fontRef>
+        </p:style>
+        <p:txBody>
+          <a:bodyPr rtlCol="0" anchor="ctr"/>
+          <a:lstStyle/>
+          <a:p>
+            <a:pPr algn="ctr"/>
+          </a:p>
+        </p:txBody>
+      </p:sp>
+      <p:sp>
+        <p:nvSpPr>
+          <p:cNvPr id="13" name="Rectangle 12"/>
+          <p:cNvSpPr/>
+          <p:nvPr/>
+        </p:nvSpPr>
+        <p:spPr>
+          <a:xfrm>
+            <a:off x="1417320" y="2276856"/>
+            <a:ext cx="9601200" cy="13716"/>
+          </a:xfrm>
+          <a:prstGeom prst="rect">
+            <a:avLst/>
+          </a:prstGeom>
+          <a:solidFill>
+            <a:srgbClr val="D2C8AF"/>
+          </a:solidFill>
+          <a:ln>
+            <a:noFill/>
+          </a:ln>
+        </p:spPr>
+        <p:style>
+          <a:lnRef idx="1">
+            <a:schemeClr val="accent1"/>
+          </a:lnRef>
+          <a:fillRef idx="3">
+            <a:schemeClr val="accent1"/>
+          </a:fillRef>
+          <a:effectRef idx="2">
+            <a:schemeClr val="accent1"/>
+          </a:effectRef>
+          <a:fontRef idx="minor">
+            <a:schemeClr val="lt1"/>
+          </a:fontRef>
+        </p:style>
+        <p:txBody>
+          <a:bodyPr rtlCol="0" anchor="ctr"/>
+          <a:lstStyle/>
+          <a:p>
+            <a:pPr algn="ctr"/>
+          </a:p>
+        </p:txBody>
+      </p:sp>
+      <p:sp>
+        <p:nvSpPr>
+          <p:cNvPr id="14" name="Rounded Rectangle 13"/>
+          <p:cNvSpPr/>
+          <p:nvPr/>
+        </p:nvSpPr>
+        <p:spPr>
+          <a:xfrm>
+            <a:off x="1600200" y="1627632"/>
+            <a:ext cx="1280160" cy="347472"/>
           </a:xfrm>
           <a:prstGeom prst="roundRect">
             <a:avLst/>
@@ -3572,14 +3922,14 @@
       </p:sp>
       <p:sp>
         <p:nvSpPr>
-          <p:cNvPr id="7" name="TextBox 6"/>
+          <p:cNvPr id="15" name="TextBox 14"/>
           <p:cNvSpPr txBox="1"/>
           <p:nvPr/>
         </p:nvSpPr>
         <p:spPr>
           <a:xfrm>
-            <a:off x="4953304" y="521208"/>
-            <a:ext cx="2286000" cy="384048"/>
+            <a:off x="1600200" y="1645920"/>
+            <a:ext cx="1280160" cy="310896"/>
           </a:xfrm>
           <a:prstGeom prst="rect">
             <a:avLst/>
@@ -3604,21 +3954,21 @@
                 </a:solidFill>
                 <a:latin typeface="Microsoft YaHei"/>
               </a:rPr>
-              <a:t>课时目标</a:t>
-            </a:r>
-          </a:p>
-        </p:txBody>
-      </p:sp>
-      <p:sp>
-        <p:nvSpPr>
-          <p:cNvPr id="8" name="TextBox 7"/>
+              <a:t>作者</a:t>
+            </a:r>
+          </a:p>
+        </p:txBody>
+      </p:sp>
+      <p:sp>
+        <p:nvSpPr>
+          <p:cNvPr id="16" name="TextBox 15"/>
           <p:cNvSpPr txBox="1"/>
           <p:nvPr/>
         </p:nvSpPr>
         <p:spPr>
           <a:xfrm>
-            <a:off x="1371600" y="960120"/>
-            <a:ext cx="9418320" cy="822960"/>
+            <a:off x="3017520" y="1627632"/>
+            <a:ext cx="7498079" cy="658368"/>
           </a:xfrm>
           <a:prstGeom prst="rect">
             <a:avLst/>
@@ -3626,40 +3976,83 @@
           <a:noFill/>
         </p:spPr>
         <p:txBody>
-          <a:bodyPr wrap="square">
+          <a:bodyPr wrap="none">
             <a:spAutoFit/>
           </a:bodyPr>
           <a:lstStyle/>
           <a:p>
-            <a:pPr algn="ctr">
+            <a:pPr algn="l">
               <a:spcAft>
                 <a:spcPts val="1000"/>
               </a:spcAft>
             </a:pPr>
             <a:r>
-              <a:rPr sz="3600" b="1">
+              <a:rPr sz="2100" b="0">
                 <a:solidFill>
-                  <a:srgbClr val="468250"/>
+                  <a:srgbClr val="28462D"/>
                 </a:solidFill>
                 <a:latin typeface="Microsoft YaHei"/>
               </a:rPr>
-              <a:t>本课目标</a:t>
-            </a:r>
-          </a:p>
-        </p:txBody>
-      </p:sp>
-      <p:sp>
-        <p:nvSpPr>
-          <p:cNvPr id="9" name="Rectangle 8"/>
+              <a:t>袁珂（现代作家，神话研究专家）</a:t>
+            </a:r>
+          </a:p>
+        </p:txBody>
+      </p:sp>
+      <p:sp>
+        <p:nvSpPr>
+          <p:cNvPr id="17" name="Rectangle 16"/>
           <p:cNvSpPr/>
           <p:nvPr/>
         </p:nvSpPr>
         <p:spPr>
           <a:xfrm>
-            <a:off x="3200400" y="1600200"/>
-            <a:ext cx="5760720" cy="27432"/>
-          </a:xfrm>
-          <a:prstGeom prst="rect">
+            <a:off x="1417320" y="3081527"/>
+            <a:ext cx="9601200" cy="13716"/>
+          </a:xfrm>
+          <a:prstGeom prst="rect">
+            <a:avLst/>
+          </a:prstGeom>
+          <a:solidFill>
+            <a:srgbClr val="D2C8AF"/>
+          </a:solidFill>
+          <a:ln>
+            <a:noFill/>
+          </a:ln>
+        </p:spPr>
+        <p:style>
+          <a:lnRef idx="1">
+            <a:schemeClr val="accent1"/>
+          </a:lnRef>
+          <a:fillRef idx="3">
+            <a:schemeClr val="accent1"/>
+          </a:fillRef>
+          <a:effectRef idx="2">
+            <a:schemeClr val="accent1"/>
+          </a:effectRef>
+          <a:fontRef idx="minor">
+            <a:schemeClr val="lt1"/>
+          </a:fontRef>
+        </p:style>
+        <p:txBody>
+          <a:bodyPr rtlCol="0" anchor="ctr"/>
+          <a:lstStyle/>
+          <a:p>
+            <a:pPr algn="ctr"/>
+          </a:p>
+        </p:txBody>
+      </p:sp>
+      <p:sp>
+        <p:nvSpPr>
+          <p:cNvPr id="18" name="Rounded Rectangle 17"/>
+          <p:cNvSpPr/>
+          <p:nvPr/>
+        </p:nvSpPr>
+        <p:spPr>
+          <a:xfrm>
+            <a:off x="1600200" y="2432303"/>
+            <a:ext cx="1280160" cy="347472"/>
+          </a:xfrm>
+          <a:prstGeom prst="roundRect">
             <a:avLst/>
           </a:prstGeom>
           <a:solidFill>
@@ -3693,25 +4086,101 @@
       </p:sp>
       <p:sp>
         <p:nvSpPr>
-          <p:cNvPr id="10" name="Rounded Rectangle 9"/>
+          <p:cNvPr id="19" name="TextBox 18"/>
+          <p:cNvSpPr txBox="1"/>
+          <p:nvPr/>
+        </p:nvSpPr>
+        <p:spPr>
+          <a:xfrm>
+            <a:off x="1600200" y="2450591"/>
+            <a:ext cx="1280160" cy="310896"/>
+          </a:xfrm>
+          <a:prstGeom prst="rect">
+            <a:avLst/>
+          </a:prstGeom>
+          <a:noFill/>
+        </p:spPr>
+        <p:txBody>
+          <a:bodyPr wrap="none">
+            <a:spAutoFit/>
+          </a:bodyPr>
+          <a:lstStyle/>
+          <a:p>
+            <a:pPr algn="ctr">
+              <a:spcAft>
+                <a:spcPts val="1000"/>
+              </a:spcAft>
+            </a:pPr>
+            <a:r>
+              <a:rPr sz="1800" b="1">
+                <a:solidFill>
+                  <a:srgbClr val="28462D"/>
+                </a:solidFill>
+                <a:latin typeface="Microsoft YaHei"/>
+              </a:rPr>
+              <a:t>文体</a:t>
+            </a:r>
+          </a:p>
+        </p:txBody>
+      </p:sp>
+      <p:sp>
+        <p:nvSpPr>
+          <p:cNvPr id="20" name="TextBox 19"/>
+          <p:cNvSpPr txBox="1"/>
+          <p:nvPr/>
+        </p:nvSpPr>
+        <p:spPr>
+          <a:xfrm>
+            <a:off x="3017520" y="2432303"/>
+            <a:ext cx="7498079" cy="658368"/>
+          </a:xfrm>
+          <a:prstGeom prst="rect">
+            <a:avLst/>
+          </a:prstGeom>
+          <a:noFill/>
+        </p:spPr>
+        <p:txBody>
+          <a:bodyPr wrap="none">
+            <a:spAutoFit/>
+          </a:bodyPr>
+          <a:lstStyle/>
+          <a:p>
+            <a:pPr algn="l">
+              <a:spcAft>
+                <a:spcPts val="1000"/>
+              </a:spcAft>
+            </a:pPr>
+            <a:r>
+              <a:rPr sz="2100" b="0">
+                <a:solidFill>
+                  <a:srgbClr val="28462D"/>
+                </a:solidFill>
+                <a:latin typeface="Microsoft YaHei"/>
+              </a:rPr>
+              <a:t>神话——用想象解释自然与人类起源</a:t>
+            </a:r>
+          </a:p>
+        </p:txBody>
+      </p:sp>
+      <p:sp>
+        <p:nvSpPr>
+          <p:cNvPr id="21" name="Rectangle 20"/>
           <p:cNvSpPr/>
           <p:nvPr/>
         </p:nvSpPr>
         <p:spPr>
           <a:xfrm>
-            <a:off x="1295704" y="1645920"/>
-            <a:ext cx="9601200" cy="2240280"/>
-          </a:xfrm>
-          <a:prstGeom prst="roundRect">
+            <a:off x="1417320" y="3886200"/>
+            <a:ext cx="9601200" cy="13716"/>
+          </a:xfrm>
+          <a:prstGeom prst="rect">
             <a:avLst/>
           </a:prstGeom>
           <a:solidFill>
-            <a:srgbClr val="F8FCF5"/>
+            <a:srgbClr val="D2C8AF"/>
           </a:solidFill>
-          <a:ln w="19050">
-            <a:solidFill>
-              <a:srgbClr val="A0C896"/>
-            </a:solidFill>
+          <a:ln>
+            <a:noFill/>
           </a:ln>
         </p:spPr>
         <p:style>
@@ -3738,20 +4207,20 @@
       </p:sp>
       <p:sp>
         <p:nvSpPr>
-          <p:cNvPr id="11" name="Oval 10"/>
+          <p:cNvPr id="22" name="Rounded Rectangle 21"/>
           <p:cNvSpPr/>
           <p:nvPr/>
         </p:nvSpPr>
         <p:spPr>
           <a:xfrm>
-            <a:off x="2255824" y="1828800"/>
-            <a:ext cx="384048" cy="384048"/>
-          </a:xfrm>
-          <a:prstGeom prst="ellipse">
+            <a:off x="1600200" y="3236976"/>
+            <a:ext cx="1444752" cy="347472"/>
+          </a:xfrm>
+          <a:prstGeom prst="roundRect">
             <a:avLst/>
           </a:prstGeom>
           <a:solidFill>
-            <a:srgbClr val="468250"/>
+            <a:srgbClr val="A0C896"/>
           </a:solidFill>
           <a:ln>
             <a:noFill/>
@@ -3781,14 +4250,14 @@
       </p:sp>
       <p:sp>
         <p:nvSpPr>
-          <p:cNvPr id="12" name="TextBox 11"/>
+          <p:cNvPr id="23" name="TextBox 22"/>
           <p:cNvSpPr txBox="1"/>
           <p:nvPr/>
         </p:nvSpPr>
         <p:spPr>
           <a:xfrm>
-            <a:off x="2255824" y="1847088"/>
-            <a:ext cx="384048" cy="365760"/>
+            <a:off x="1600200" y="3255264"/>
+            <a:ext cx="1444752" cy="310896"/>
           </a:xfrm>
           <a:prstGeom prst="rect">
             <a:avLst/>
@@ -3807,27 +4276,27 @@
               </a:spcAft>
             </a:pPr>
             <a:r>
-              <a:rPr sz="1600" b="1">
+              <a:rPr sz="1800" b="1">
                 <a:solidFill>
-                  <a:srgbClr val="FFFFFF"/>
+                  <a:srgbClr val="28462D"/>
                 </a:solidFill>
                 <a:latin typeface="Microsoft YaHei"/>
               </a:rPr>
-              <a:t>1</a:t>
-            </a:r>
-          </a:p>
-        </p:txBody>
-      </p:sp>
-      <p:sp>
-        <p:nvSpPr>
-          <p:cNvPr id="13" name="TextBox 12"/>
+              <a:t>改写特点</a:t>
+            </a:r>
+          </a:p>
+        </p:txBody>
+      </p:sp>
+      <p:sp>
+        <p:nvSpPr>
+          <p:cNvPr id="24" name="TextBox 23"/>
           <p:cNvSpPr txBox="1"/>
           <p:nvPr/>
         </p:nvSpPr>
         <p:spPr>
           <a:xfrm>
-            <a:off x="2758744" y="1810512"/>
-            <a:ext cx="7772400" cy="502920"/>
+            <a:off x="3182112" y="3236976"/>
+            <a:ext cx="7333488" cy="658368"/>
           </a:xfrm>
           <a:prstGeom prst="rect">
             <a:avLst/>
@@ -3846,33 +4315,33 @@
               </a:spcAft>
             </a:pPr>
             <a:r>
-              <a:rPr sz="2400" b="0">
+              <a:rPr sz="2100" b="0">
                 <a:solidFill>
                   <a:srgbClr val="28462D"/>
                 </a:solidFill>
                 <a:latin typeface="Microsoft YaHei"/>
               </a:rPr>
-              <a:t>概括女娲造人过程，梳理文章写作思路</a:t>
-            </a:r>
-          </a:p>
-        </p:txBody>
-      </p:sp>
-      <p:sp>
-        <p:nvSpPr>
-          <p:cNvPr id="14" name="Oval 13"/>
+              <a:t>在古籍记载基础上增删改写，赋予现代意识</a:t>
+            </a:r>
+          </a:p>
+        </p:txBody>
+      </p:sp>
+      <p:sp>
+        <p:nvSpPr>
+          <p:cNvPr id="25" name="Rectangle 24"/>
           <p:cNvSpPr/>
           <p:nvPr/>
         </p:nvSpPr>
         <p:spPr>
           <a:xfrm>
-            <a:off x="2255824" y="2395728"/>
-            <a:ext cx="384048" cy="384048"/>
-          </a:xfrm>
-          <a:prstGeom prst="ellipse">
+            <a:off x="1417320" y="4690872"/>
+            <a:ext cx="9601200" cy="13716"/>
+          </a:xfrm>
+          <a:prstGeom prst="rect">
             <a:avLst/>
           </a:prstGeom>
           <a:solidFill>
-            <a:srgbClr val="468250"/>
+            <a:srgbClr val="D2C8AF"/>
           </a:solidFill>
           <a:ln>
             <a:noFill/>
@@ -3902,14 +4371,57 @@
       </p:sp>
       <p:sp>
         <p:nvSpPr>
-          <p:cNvPr id="15" name="TextBox 14"/>
+          <p:cNvPr id="26" name="Rounded Rectangle 25"/>
+          <p:cNvSpPr/>
+          <p:nvPr/>
+        </p:nvSpPr>
+        <p:spPr>
+          <a:xfrm>
+            <a:off x="1600200" y="4041648"/>
+            <a:ext cx="1444752" cy="347472"/>
+          </a:xfrm>
+          <a:prstGeom prst="roundRect">
+            <a:avLst/>
+          </a:prstGeom>
+          <a:solidFill>
+            <a:srgbClr val="A0C896"/>
+          </a:solidFill>
+          <a:ln>
+            <a:noFill/>
+          </a:ln>
+        </p:spPr>
+        <p:style>
+          <a:lnRef idx="1">
+            <a:schemeClr val="accent1"/>
+          </a:lnRef>
+          <a:fillRef idx="3">
+            <a:schemeClr val="accent1"/>
+          </a:fillRef>
+          <a:effectRef idx="2">
+            <a:schemeClr val="accent1"/>
+          </a:effectRef>
+          <a:fontRef idx="minor">
+            <a:schemeClr val="lt1"/>
+          </a:fontRef>
+        </p:style>
+        <p:txBody>
+          <a:bodyPr rtlCol="0" anchor="ctr"/>
+          <a:lstStyle/>
+          <a:p>
+            <a:pPr algn="ctr"/>
+          </a:p>
+        </p:txBody>
+      </p:sp>
+      <p:sp>
+        <p:nvSpPr>
+          <p:cNvPr id="27" name="TextBox 26"/>
           <p:cNvSpPr txBox="1"/>
           <p:nvPr/>
         </p:nvSpPr>
         <p:spPr>
           <a:xfrm>
-            <a:off x="2255824" y="2414016"/>
-            <a:ext cx="384048" cy="365760"/>
+            <a:off x="1600200" y="4059936"/>
+            <a:ext cx="1444752" cy="310896"/>
           </a:xfrm>
           <a:prstGeom prst="rect">
             <a:avLst/>
@@ -3928,27 +4440,27 @@
               </a:spcAft>
             </a:pPr>
             <a:r>
-              <a:rPr sz="1600" b="1">
+              <a:rPr sz="1800" b="1">
                 <a:solidFill>
-                  <a:srgbClr val="FFFFFF"/>
+                  <a:srgbClr val="28462D"/>
                 </a:solidFill>
                 <a:latin typeface="Microsoft YaHei"/>
               </a:rPr>
-              <a:t>2</a:t>
-            </a:r>
-          </a:p>
-        </p:txBody>
-      </p:sp>
-      <p:sp>
-        <p:nvSpPr>
-          <p:cNvPr id="16" name="TextBox 15"/>
+              <a:t>对比材料</a:t>
+            </a:r>
+          </a:p>
+        </p:txBody>
+      </p:sp>
+      <p:sp>
+        <p:nvSpPr>
+          <p:cNvPr id="28" name="TextBox 27"/>
           <p:cNvSpPr txBox="1"/>
           <p:nvPr/>
         </p:nvSpPr>
         <p:spPr>
           <a:xfrm>
-            <a:off x="2758744" y="2377440"/>
-            <a:ext cx="7772400" cy="502920"/>
+            <a:off x="3182112" y="4041648"/>
+            <a:ext cx="7333488" cy="658368"/>
           </a:xfrm>
           <a:prstGeom prst="rect">
             <a:avLst/>
@@ -3967,134 +4479,13 @@
               </a:spcAft>
             </a:pPr>
             <a:r>
-              <a:rPr sz="2400" b="0">
+              <a:rPr sz="2100" b="0">
                 <a:solidFill>
                   <a:srgbClr val="28462D"/>
                 </a:solidFill>
                 <a:latin typeface="Microsoft YaHei"/>
               </a:rPr>
-              <a:t>比较古籍与课文，体会作者的想象与创造</a:t>
-            </a:r>
-          </a:p>
-        </p:txBody>
-      </p:sp>
-      <p:sp>
-        <p:nvSpPr>
-          <p:cNvPr id="17" name="Oval 16"/>
-          <p:cNvSpPr/>
-          <p:nvPr/>
-        </p:nvSpPr>
-        <p:spPr>
-          <a:xfrm>
-            <a:off x="2255824" y="2962656"/>
-            <a:ext cx="384048" cy="384048"/>
-          </a:xfrm>
-          <a:prstGeom prst="ellipse">
-            <a:avLst/>
-          </a:prstGeom>
-          <a:solidFill>
-            <a:srgbClr val="468250"/>
-          </a:solidFill>
-          <a:ln>
-            <a:noFill/>
-          </a:ln>
-        </p:spPr>
-        <p:style>
-          <a:lnRef idx="1">
-            <a:schemeClr val="accent1"/>
-          </a:lnRef>
-          <a:fillRef idx="3">
-            <a:schemeClr val="accent1"/>
-          </a:fillRef>
-          <a:effectRef idx="2">
-            <a:schemeClr val="accent1"/>
-          </a:effectRef>
-          <a:fontRef idx="minor">
-            <a:schemeClr val="lt1"/>
-          </a:fontRef>
-        </p:style>
-        <p:txBody>
-          <a:bodyPr rtlCol="0" anchor="ctr"/>
-          <a:lstStyle/>
-          <a:p>
-            <a:pPr algn="ctr"/>
-          </a:p>
-        </p:txBody>
-      </p:sp>
-      <p:sp>
-        <p:nvSpPr>
-          <p:cNvPr id="18" name="TextBox 17"/>
-          <p:cNvSpPr txBox="1"/>
-          <p:nvPr/>
-        </p:nvSpPr>
-        <p:spPr>
-          <a:xfrm>
-            <a:off x="2255824" y="2980944"/>
-            <a:ext cx="384048" cy="365760"/>
-          </a:xfrm>
-          <a:prstGeom prst="rect">
-            <a:avLst/>
-          </a:prstGeom>
-          <a:noFill/>
-        </p:spPr>
-        <p:txBody>
-          <a:bodyPr wrap="none">
-            <a:spAutoFit/>
-          </a:bodyPr>
-          <a:lstStyle/>
-          <a:p>
-            <a:pPr algn="ctr">
-              <a:spcAft>
-                <a:spcPts val="1000"/>
-              </a:spcAft>
-            </a:pPr>
-            <a:r>
-              <a:rPr sz="1600" b="1">
-                <a:solidFill>
-                  <a:srgbClr val="FFFFFF"/>
-                </a:solidFill>
-                <a:latin typeface="Microsoft YaHei"/>
-              </a:rPr>
-              <a:t>3</a:t>
-            </a:r>
-          </a:p>
-        </p:txBody>
-      </p:sp>
-      <p:sp>
-        <p:nvSpPr>
-          <p:cNvPr id="19" name="TextBox 18"/>
-          <p:cNvSpPr txBox="1"/>
-          <p:nvPr/>
-        </p:nvSpPr>
-        <p:spPr>
-          <a:xfrm>
-            <a:off x="2758744" y="2944368"/>
-            <a:ext cx="7772400" cy="502920"/>
-          </a:xfrm>
-          <a:prstGeom prst="rect">
-            <a:avLst/>
-          </a:prstGeom>
-          <a:noFill/>
-        </p:spPr>
-        <p:txBody>
-          <a:bodyPr wrap="none">
-            <a:spAutoFit/>
-          </a:bodyPr>
-          <a:lstStyle/>
-          <a:p>
-            <a:pPr algn="l">
-              <a:spcAft>
-                <a:spcPts val="1000"/>
-              </a:spcAft>
-            </a:pPr>
-            <a:r>
-              <a:rPr sz="2400" b="0">
-                <a:solidFill>
-                  <a:srgbClr val="28462D"/>
-                </a:solidFill>
-                <a:latin typeface="Microsoft YaHei"/>
-              </a:rPr>
-              <a:t>感悟神话中蕴含的对生命与创造的礼赞</a:t>
+              <a:t>教材「阅读提示」中的《风俗通》记载</a:t>
             </a:r>
           </a:p>
         </p:txBody>
@@ -4240,8 +4631,342 @@
         </p:nvSpPr>
         <p:spPr>
           <a:xfrm>
-            <a:off x="4953304" y="1005840"/>
-            <a:ext cx="2286000" cy="411480"/>
+            <a:off x="502920" y="384048"/>
+            <a:ext cx="2011680" cy="384048"/>
+          </a:xfrm>
+          <a:prstGeom prst="roundRect">
+            <a:avLst/>
+          </a:prstGeom>
+          <a:solidFill>
+            <a:srgbClr val="468250"/>
+          </a:solidFill>
+          <a:ln>
+            <a:noFill/>
+          </a:ln>
+        </p:spPr>
+        <p:style>
+          <a:lnRef idx="1">
+            <a:schemeClr val="accent1"/>
+          </a:lnRef>
+          <a:fillRef idx="3">
+            <a:schemeClr val="accent1"/>
+          </a:fillRef>
+          <a:effectRef idx="2">
+            <a:schemeClr val="accent1"/>
+          </a:effectRef>
+          <a:fontRef idx="minor">
+            <a:schemeClr val="lt1"/>
+          </a:fontRef>
+        </p:style>
+        <p:txBody>
+          <a:bodyPr rtlCol="0" anchor="ctr"/>
+          <a:lstStyle/>
+          <a:p>
+            <a:pPr algn="ctr"/>
+          </a:p>
+        </p:txBody>
+      </p:sp>
+      <p:sp>
+        <p:nvSpPr>
+          <p:cNvPr id="7" name="TextBox 6"/>
+          <p:cNvSpPr txBox="1"/>
+          <p:nvPr/>
+        </p:nvSpPr>
+        <p:spPr>
+          <a:xfrm>
+            <a:off x="502920" y="402336"/>
+            <a:ext cx="2011680" cy="347472"/>
+          </a:xfrm>
+          <a:prstGeom prst="rect">
+            <a:avLst/>
+          </a:prstGeom>
+          <a:noFill/>
+        </p:spPr>
+        <p:txBody>
+          <a:bodyPr wrap="none">
+            <a:spAutoFit/>
+          </a:bodyPr>
+          <a:lstStyle/>
+          <a:p>
+            <a:pPr algn="ctr">
+              <a:spcAft>
+                <a:spcPts val="1000"/>
+              </a:spcAft>
+            </a:pPr>
+            <a:r>
+              <a:rPr sz="1600" b="1">
+                <a:solidFill>
+                  <a:srgbClr val="FFFFFF"/>
+                </a:solidFill>
+                <a:latin typeface="Microsoft YaHei"/>
+              </a:rPr>
+              <a:t>情节笔记</a:t>
+            </a:r>
+          </a:p>
+        </p:txBody>
+      </p:sp>
+      <p:sp>
+        <p:nvSpPr>
+          <p:cNvPr id="8" name="TextBox 7"/>
+          <p:cNvSpPr txBox="1"/>
+          <p:nvPr/>
+        </p:nvSpPr>
+        <p:spPr>
+          <a:xfrm>
+            <a:off x="1371600" y="384048"/>
+            <a:ext cx="9418320" cy="822960"/>
+          </a:xfrm>
+          <a:prstGeom prst="rect">
+            <a:avLst/>
+          </a:prstGeom>
+          <a:noFill/>
+        </p:spPr>
+        <p:txBody>
+          <a:bodyPr wrap="square">
+            <a:spAutoFit/>
+          </a:bodyPr>
+          <a:lstStyle/>
+          <a:p>
+            <a:pPr algn="ctr">
+              <a:spcAft>
+                <a:spcPts val="1000"/>
+              </a:spcAft>
+            </a:pPr>
+            <a:r>
+              <a:rPr sz="3400" b="1">
+                <a:solidFill>
+                  <a:srgbClr val="468250"/>
+                </a:solidFill>
+                <a:latin typeface="Microsoft YaHei"/>
+              </a:rPr>
+              <a:t>造人过程</a:t>
+            </a:r>
+          </a:p>
+        </p:txBody>
+      </p:sp>
+      <p:sp>
+        <p:nvSpPr>
+          <p:cNvPr id="9" name="Rounded Rectangle 8"/>
+          <p:cNvSpPr/>
+          <p:nvPr/>
+        </p:nvSpPr>
+        <p:spPr>
+          <a:xfrm>
+            <a:off x="1067104" y="1143000"/>
+            <a:ext cx="10058400" cy="3721608"/>
+          </a:xfrm>
+          <a:prstGeom prst="roundRect">
+            <a:avLst/>
+          </a:prstGeom>
+          <a:solidFill>
+            <a:srgbClr val="FFFCEB"/>
+          </a:solidFill>
+          <a:ln w="25400">
+            <a:solidFill>
+              <a:srgbClr val="5A8C5A"/>
+            </a:solidFill>
+          </a:ln>
+        </p:spPr>
+        <p:style>
+          <a:lnRef idx="1">
+            <a:schemeClr val="accent1"/>
+          </a:lnRef>
+          <a:fillRef idx="3">
+            <a:schemeClr val="accent1"/>
+          </a:fillRef>
+          <a:effectRef idx="2">
+            <a:schemeClr val="accent1"/>
+          </a:effectRef>
+          <a:fontRef idx="minor">
+            <a:schemeClr val="lt1"/>
+          </a:fontRef>
+        </p:style>
+        <p:txBody>
+          <a:bodyPr rtlCol="0" anchor="ctr"/>
+          <a:lstStyle/>
+          <a:p>
+            <a:pPr algn="ctr"/>
+          </a:p>
+        </p:txBody>
+      </p:sp>
+      <p:sp>
+        <p:nvSpPr>
+          <p:cNvPr id="10" name="Rectangle 9"/>
+          <p:cNvSpPr/>
+          <p:nvPr/>
+        </p:nvSpPr>
+        <p:spPr>
+          <a:xfrm>
+            <a:off x="1067104" y="1143000"/>
+            <a:ext cx="10058400" cy="384048"/>
+          </a:xfrm>
+          <a:prstGeom prst="rect">
+            <a:avLst/>
+          </a:prstGeom>
+          <a:solidFill>
+            <a:srgbClr val="468250"/>
+          </a:solidFill>
+          <a:ln>
+            <a:noFill/>
+          </a:ln>
+        </p:spPr>
+        <p:style>
+          <a:lnRef idx="1">
+            <a:schemeClr val="accent1"/>
+          </a:lnRef>
+          <a:fillRef idx="3">
+            <a:schemeClr val="accent1"/>
+          </a:fillRef>
+          <a:effectRef idx="2">
+            <a:schemeClr val="accent1"/>
+          </a:effectRef>
+          <a:fontRef idx="minor">
+            <a:schemeClr val="lt1"/>
+          </a:fontRef>
+        </p:style>
+        <p:txBody>
+          <a:bodyPr rtlCol="0" anchor="ctr"/>
+          <a:lstStyle/>
+          <a:p>
+            <a:pPr algn="ctr"/>
+          </a:p>
+        </p:txBody>
+      </p:sp>
+      <p:sp>
+        <p:nvSpPr>
+          <p:cNvPr id="11" name="TextBox 10"/>
+          <p:cNvSpPr txBox="1"/>
+          <p:nvPr/>
+        </p:nvSpPr>
+        <p:spPr>
+          <a:xfrm>
+            <a:off x="1067104" y="1179576"/>
+            <a:ext cx="10058400" cy="347472"/>
+          </a:xfrm>
+          <a:prstGeom prst="rect">
+            <a:avLst/>
+          </a:prstGeom>
+          <a:noFill/>
+        </p:spPr>
+        <p:txBody>
+          <a:bodyPr wrap="none">
+            <a:spAutoFit/>
+          </a:bodyPr>
+          <a:lstStyle/>
+          <a:p>
+            <a:pPr algn="ctr">
+              <a:spcAft>
+                <a:spcPts val="1000"/>
+              </a:spcAft>
+            </a:pPr>
+            <a:r>
+              <a:rPr sz="1800" b="1">
+                <a:solidFill>
+                  <a:srgbClr val="FFFFFF"/>
+                </a:solidFill>
+                <a:latin typeface="Microsoft YaHei"/>
+              </a:rPr>
+              <a:t>📝  课堂笔记  —  请摘抄要点</a:t>
+            </a:r>
+          </a:p>
+        </p:txBody>
+      </p:sp>
+      <p:sp>
+        <p:nvSpPr>
+          <p:cNvPr id="12" name="Rectangle 11"/>
+          <p:cNvSpPr/>
+          <p:nvPr/>
+        </p:nvSpPr>
+        <p:spPr>
+          <a:xfrm>
+            <a:off x="1570024" y="1527048"/>
+            <a:ext cx="27432" cy="3337560"/>
+          </a:xfrm>
+          <a:prstGeom prst="rect">
+            <a:avLst/>
+          </a:prstGeom>
+          <a:solidFill>
+            <a:srgbClr val="DC5050"/>
+          </a:solidFill>
+          <a:ln>
+            <a:noFill/>
+          </a:ln>
+        </p:spPr>
+        <p:style>
+          <a:lnRef idx="1">
+            <a:schemeClr val="accent1"/>
+          </a:lnRef>
+          <a:fillRef idx="3">
+            <a:schemeClr val="accent1"/>
+          </a:fillRef>
+          <a:effectRef idx="2">
+            <a:schemeClr val="accent1"/>
+          </a:effectRef>
+          <a:fontRef idx="minor">
+            <a:schemeClr val="lt1"/>
+          </a:fontRef>
+        </p:style>
+        <p:txBody>
+          <a:bodyPr rtlCol="0" anchor="ctr"/>
+          <a:lstStyle/>
+          <a:p>
+            <a:pPr algn="ctr"/>
+          </a:p>
+        </p:txBody>
+      </p:sp>
+      <p:sp>
+        <p:nvSpPr>
+          <p:cNvPr id="13" name="Rectangle 12"/>
+          <p:cNvSpPr/>
+          <p:nvPr/>
+        </p:nvSpPr>
+        <p:spPr>
+          <a:xfrm>
+            <a:off x="1417320" y="2276856"/>
+            <a:ext cx="9601200" cy="13716"/>
+          </a:xfrm>
+          <a:prstGeom prst="rect">
+            <a:avLst/>
+          </a:prstGeom>
+          <a:solidFill>
+            <a:srgbClr val="D2C8AF"/>
+          </a:solidFill>
+          <a:ln>
+            <a:noFill/>
+          </a:ln>
+        </p:spPr>
+        <p:style>
+          <a:lnRef idx="1">
+            <a:schemeClr val="accent1"/>
+          </a:lnRef>
+          <a:fillRef idx="3">
+            <a:schemeClr val="accent1"/>
+          </a:fillRef>
+          <a:effectRef idx="2">
+            <a:schemeClr val="accent1"/>
+          </a:effectRef>
+          <a:fontRef idx="minor">
+            <a:schemeClr val="lt1"/>
+          </a:fontRef>
+        </p:style>
+        <p:txBody>
+          <a:bodyPr rtlCol="0" anchor="ctr"/>
+          <a:lstStyle/>
+          <a:p>
+            <a:pPr algn="ctr"/>
+          </a:p>
+        </p:txBody>
+      </p:sp>
+      <p:sp>
+        <p:nvSpPr>
+          <p:cNvPr id="14" name="Rounded Rectangle 13"/>
+          <p:cNvSpPr/>
+          <p:nvPr/>
+        </p:nvSpPr>
+        <p:spPr>
+          <a:xfrm>
+            <a:off x="1600200" y="1627632"/>
+            <a:ext cx="1280160" cy="347472"/>
           </a:xfrm>
           <a:prstGeom prst="roundRect">
             <a:avLst/>
@@ -4277,14 +5002,14 @@
       </p:sp>
       <p:sp>
         <p:nvSpPr>
-          <p:cNvPr id="7" name="TextBox 6"/>
+          <p:cNvPr id="15" name="TextBox 14"/>
           <p:cNvSpPr txBox="1"/>
           <p:nvPr/>
         </p:nvSpPr>
         <p:spPr>
           <a:xfrm>
-            <a:off x="4953304" y="1024128"/>
-            <a:ext cx="2286000" cy="384048"/>
+            <a:off x="1600200" y="1645920"/>
+            <a:ext cx="1280160" cy="310896"/>
           </a:xfrm>
           <a:prstGeom prst="rect">
             <a:avLst/>
@@ -4309,21 +5034,21 @@
                 </a:solidFill>
                 <a:latin typeface="Microsoft YaHei"/>
               </a:rPr>
-              <a:t>想一想</a:t>
-            </a:r>
-          </a:p>
-        </p:txBody>
-      </p:sp>
-      <p:sp>
-        <p:nvSpPr>
-          <p:cNvPr id="8" name="TextBox 7"/>
+              <a:t>起因</a:t>
+            </a:r>
+          </a:p>
+        </p:txBody>
+      </p:sp>
+      <p:sp>
+        <p:nvSpPr>
+          <p:cNvPr id="16" name="TextBox 15"/>
           <p:cNvSpPr txBox="1"/>
           <p:nvPr/>
         </p:nvSpPr>
         <p:spPr>
           <a:xfrm>
-            <a:off x="1371600" y="1600200"/>
-            <a:ext cx="9418320" cy="822960"/>
+            <a:off x="3017520" y="1627632"/>
+            <a:ext cx="7498079" cy="658368"/>
           </a:xfrm>
           <a:prstGeom prst="rect">
             <a:avLst/>
@@ -4331,40 +5056,83 @@
           <a:noFill/>
         </p:spPr>
         <p:txBody>
-          <a:bodyPr wrap="square">
+          <a:bodyPr wrap="none">
             <a:spAutoFit/>
           </a:bodyPr>
           <a:lstStyle/>
           <a:p>
-            <a:pPr algn="ctr">
+            <a:pPr algn="l">
               <a:spcAft>
                 <a:spcPts val="1000"/>
               </a:spcAft>
             </a:pPr>
             <a:r>
-              <a:rPr sz="3200" b="1">
+              <a:rPr sz="2100" b="0">
                 <a:solidFill>
-                  <a:srgbClr val="468250"/>
+                  <a:srgbClr val="28462D"/>
                 </a:solidFill>
                 <a:latin typeface="Microsoft YaHei"/>
               </a:rPr>
-              <a:t>为什么古人要想象一位女神来创造人类？</a:t>
-            </a:r>
-          </a:p>
-        </p:txBody>
-      </p:sp>
-      <p:sp>
-        <p:nvSpPr>
-          <p:cNvPr id="9" name="Rectangle 8"/>
+              <a:t>女娲行走世间，感到孤独寂寞</a:t>
+            </a:r>
+          </a:p>
+        </p:txBody>
+      </p:sp>
+      <p:sp>
+        <p:nvSpPr>
+          <p:cNvPr id="17" name="Rectangle 16"/>
           <p:cNvSpPr/>
           <p:nvPr/>
         </p:nvSpPr>
         <p:spPr>
           <a:xfrm>
-            <a:off x="3200400" y="4389120"/>
-            <a:ext cx="5760720" cy="27432"/>
-          </a:xfrm>
-          <a:prstGeom prst="rect">
+            <a:off x="1417320" y="3081527"/>
+            <a:ext cx="9601200" cy="13716"/>
+          </a:xfrm>
+          <a:prstGeom prst="rect">
+            <a:avLst/>
+          </a:prstGeom>
+          <a:solidFill>
+            <a:srgbClr val="D2C8AF"/>
+          </a:solidFill>
+          <a:ln>
+            <a:noFill/>
+          </a:ln>
+        </p:spPr>
+        <p:style>
+          <a:lnRef idx="1">
+            <a:schemeClr val="accent1"/>
+          </a:lnRef>
+          <a:fillRef idx="3">
+            <a:schemeClr val="accent1"/>
+          </a:fillRef>
+          <a:effectRef idx="2">
+            <a:schemeClr val="accent1"/>
+          </a:effectRef>
+          <a:fontRef idx="minor">
+            <a:schemeClr val="lt1"/>
+          </a:fontRef>
+        </p:style>
+        <p:txBody>
+          <a:bodyPr rtlCol="0" anchor="ctr"/>
+          <a:lstStyle/>
+          <a:p>
+            <a:pPr algn="ctr"/>
+          </a:p>
+        </p:txBody>
+      </p:sp>
+      <p:sp>
+        <p:nvSpPr>
+          <p:cNvPr id="18" name="Rounded Rectangle 17"/>
+          <p:cNvSpPr/>
+          <p:nvPr/>
+        </p:nvSpPr>
+        <p:spPr>
+          <a:xfrm>
+            <a:off x="1600200" y="2432303"/>
+            <a:ext cx="1280160" cy="347472"/>
+          </a:xfrm>
+          <a:prstGeom prst="roundRect">
             <a:avLst/>
           </a:prstGeom>
           <a:solidFill>
@@ -4398,14 +5166,14 @@
       </p:sp>
       <p:sp>
         <p:nvSpPr>
-          <p:cNvPr id="10" name="TextBox 9"/>
+          <p:cNvPr id="19" name="TextBox 18"/>
           <p:cNvSpPr txBox="1"/>
           <p:nvPr/>
         </p:nvSpPr>
         <p:spPr>
           <a:xfrm>
-            <a:off x="1828800" y="4663440"/>
-            <a:ext cx="8503920" cy="914400"/>
+            <a:off x="1600200" y="2450591"/>
+            <a:ext cx="1280160" cy="310896"/>
           </a:xfrm>
           <a:prstGeom prst="rect">
             <a:avLst/>
@@ -4424,13 +5192,380 @@
               </a:spcAft>
             </a:pPr>
             <a:r>
-              <a:rPr sz="2200" b="0">
+              <a:rPr sz="1800" b="1">
                 <a:solidFill>
-                  <a:srgbClr val="468250"/>
+                  <a:srgbClr val="28462D"/>
                 </a:solidFill>
                 <a:latin typeface="Microsoft YaHei"/>
               </a:rPr>
-              <a:t>这是对「人从哪里来、为何需要同伴」的诗意追问</a:t>
+              <a:t>方法一</a:t>
+            </a:r>
+          </a:p>
+        </p:txBody>
+      </p:sp>
+      <p:sp>
+        <p:nvSpPr>
+          <p:cNvPr id="20" name="TextBox 19"/>
+          <p:cNvSpPr txBox="1"/>
+          <p:nvPr/>
+        </p:nvSpPr>
+        <p:spPr>
+          <a:xfrm>
+            <a:off x="3017520" y="2432303"/>
+            <a:ext cx="7498079" cy="658368"/>
+          </a:xfrm>
+          <a:prstGeom prst="rect">
+            <a:avLst/>
+          </a:prstGeom>
+          <a:noFill/>
+        </p:spPr>
+        <p:txBody>
+          <a:bodyPr wrap="none">
+            <a:spAutoFit/>
+          </a:bodyPr>
+          <a:lstStyle/>
+          <a:p>
+            <a:pPr algn="l">
+              <a:spcAft>
+                <a:spcPts val="1000"/>
+              </a:spcAft>
+            </a:pPr>
+            <a:r>
+              <a:rPr sz="2100" b="0">
+                <a:solidFill>
+                  <a:srgbClr val="28462D"/>
+                </a:solidFill>
+                <a:latin typeface="Microsoft YaHei"/>
+              </a:rPr>
+              <a:t>黄泥和水，揉成小泥人，泥人落地即活</a:t>
+            </a:r>
+          </a:p>
+        </p:txBody>
+      </p:sp>
+      <p:sp>
+        <p:nvSpPr>
+          <p:cNvPr id="21" name="Rectangle 20"/>
+          <p:cNvSpPr/>
+          <p:nvPr/>
+        </p:nvSpPr>
+        <p:spPr>
+          <a:xfrm>
+            <a:off x="1417320" y="3886200"/>
+            <a:ext cx="9601200" cy="13716"/>
+          </a:xfrm>
+          <a:prstGeom prst="rect">
+            <a:avLst/>
+          </a:prstGeom>
+          <a:solidFill>
+            <a:srgbClr val="D2C8AF"/>
+          </a:solidFill>
+          <a:ln>
+            <a:noFill/>
+          </a:ln>
+        </p:spPr>
+        <p:style>
+          <a:lnRef idx="1">
+            <a:schemeClr val="accent1"/>
+          </a:lnRef>
+          <a:fillRef idx="3">
+            <a:schemeClr val="accent1"/>
+          </a:fillRef>
+          <a:effectRef idx="2">
+            <a:schemeClr val="accent1"/>
+          </a:effectRef>
+          <a:fontRef idx="minor">
+            <a:schemeClr val="lt1"/>
+          </a:fontRef>
+        </p:style>
+        <p:txBody>
+          <a:bodyPr rtlCol="0" anchor="ctr"/>
+          <a:lstStyle/>
+          <a:p>
+            <a:pPr algn="ctr"/>
+          </a:p>
+        </p:txBody>
+      </p:sp>
+      <p:sp>
+        <p:nvSpPr>
+          <p:cNvPr id="22" name="Rounded Rectangle 21"/>
+          <p:cNvSpPr/>
+          <p:nvPr/>
+        </p:nvSpPr>
+        <p:spPr>
+          <a:xfrm>
+            <a:off x="1600200" y="3236976"/>
+            <a:ext cx="1280160" cy="347472"/>
+          </a:xfrm>
+          <a:prstGeom prst="roundRect">
+            <a:avLst/>
+          </a:prstGeom>
+          <a:solidFill>
+            <a:srgbClr val="A0C896"/>
+          </a:solidFill>
+          <a:ln>
+            <a:noFill/>
+          </a:ln>
+        </p:spPr>
+        <p:style>
+          <a:lnRef idx="1">
+            <a:schemeClr val="accent1"/>
+          </a:lnRef>
+          <a:fillRef idx="3">
+            <a:schemeClr val="accent1"/>
+          </a:fillRef>
+          <a:effectRef idx="2">
+            <a:schemeClr val="accent1"/>
+          </a:effectRef>
+          <a:fontRef idx="minor">
+            <a:schemeClr val="lt1"/>
+          </a:fontRef>
+        </p:style>
+        <p:txBody>
+          <a:bodyPr rtlCol="0" anchor="ctr"/>
+          <a:lstStyle/>
+          <a:p>
+            <a:pPr algn="ctr"/>
+          </a:p>
+        </p:txBody>
+      </p:sp>
+      <p:sp>
+        <p:nvSpPr>
+          <p:cNvPr id="23" name="TextBox 22"/>
+          <p:cNvSpPr txBox="1"/>
+          <p:nvPr/>
+        </p:nvSpPr>
+        <p:spPr>
+          <a:xfrm>
+            <a:off x="1600200" y="3255264"/>
+            <a:ext cx="1280160" cy="310896"/>
+          </a:xfrm>
+          <a:prstGeom prst="rect">
+            <a:avLst/>
+          </a:prstGeom>
+          <a:noFill/>
+        </p:spPr>
+        <p:txBody>
+          <a:bodyPr wrap="none">
+            <a:spAutoFit/>
+          </a:bodyPr>
+          <a:lstStyle/>
+          <a:p>
+            <a:pPr algn="ctr">
+              <a:spcAft>
+                <a:spcPts val="1000"/>
+              </a:spcAft>
+            </a:pPr>
+            <a:r>
+              <a:rPr sz="1800" b="1">
+                <a:solidFill>
+                  <a:srgbClr val="28462D"/>
+                </a:solidFill>
+                <a:latin typeface="Microsoft YaHei"/>
+              </a:rPr>
+              <a:t>方法二</a:t>
+            </a:r>
+          </a:p>
+        </p:txBody>
+      </p:sp>
+      <p:sp>
+        <p:nvSpPr>
+          <p:cNvPr id="24" name="TextBox 23"/>
+          <p:cNvSpPr txBox="1"/>
+          <p:nvPr/>
+        </p:nvSpPr>
+        <p:spPr>
+          <a:xfrm>
+            <a:off x="3017520" y="3236976"/>
+            <a:ext cx="7498079" cy="658368"/>
+          </a:xfrm>
+          <a:prstGeom prst="rect">
+            <a:avLst/>
+          </a:prstGeom>
+          <a:noFill/>
+        </p:spPr>
+        <p:txBody>
+          <a:bodyPr wrap="none">
+            <a:spAutoFit/>
+          </a:bodyPr>
+          <a:lstStyle/>
+          <a:p>
+            <a:pPr algn="l">
+              <a:spcAft>
+                <a:spcPts val="1000"/>
+              </a:spcAft>
+            </a:pPr>
+            <a:r>
+              <a:rPr sz="2100" b="0">
+                <a:solidFill>
+                  <a:srgbClr val="28462D"/>
+                </a:solidFill>
+                <a:latin typeface="Microsoft YaHei"/>
+              </a:rPr>
+              <a:t>藤条蘸泥浆挥洒，溅落的泥点也变成人</a:t>
+            </a:r>
+          </a:p>
+        </p:txBody>
+      </p:sp>
+      <p:sp>
+        <p:nvSpPr>
+          <p:cNvPr id="25" name="Rectangle 24"/>
+          <p:cNvSpPr/>
+          <p:nvPr/>
+        </p:nvSpPr>
+        <p:spPr>
+          <a:xfrm>
+            <a:off x="1417320" y="4690872"/>
+            <a:ext cx="9601200" cy="13716"/>
+          </a:xfrm>
+          <a:prstGeom prst="rect">
+            <a:avLst/>
+          </a:prstGeom>
+          <a:solidFill>
+            <a:srgbClr val="D2C8AF"/>
+          </a:solidFill>
+          <a:ln>
+            <a:noFill/>
+          </a:ln>
+        </p:spPr>
+        <p:style>
+          <a:lnRef idx="1">
+            <a:schemeClr val="accent1"/>
+          </a:lnRef>
+          <a:fillRef idx="3">
+            <a:schemeClr val="accent1"/>
+          </a:fillRef>
+          <a:effectRef idx="2">
+            <a:schemeClr val="accent1"/>
+          </a:effectRef>
+          <a:fontRef idx="minor">
+            <a:schemeClr val="lt1"/>
+          </a:fontRef>
+        </p:style>
+        <p:txBody>
+          <a:bodyPr rtlCol="0" anchor="ctr"/>
+          <a:lstStyle/>
+          <a:p>
+            <a:pPr algn="ctr"/>
+          </a:p>
+        </p:txBody>
+      </p:sp>
+      <p:sp>
+        <p:nvSpPr>
+          <p:cNvPr id="26" name="Rounded Rectangle 25"/>
+          <p:cNvSpPr/>
+          <p:nvPr/>
+        </p:nvSpPr>
+        <p:spPr>
+          <a:xfrm>
+            <a:off x="1600200" y="4041648"/>
+            <a:ext cx="1280160" cy="347472"/>
+          </a:xfrm>
+          <a:prstGeom prst="roundRect">
+            <a:avLst/>
+          </a:prstGeom>
+          <a:solidFill>
+            <a:srgbClr val="A0C896"/>
+          </a:solidFill>
+          <a:ln>
+            <a:noFill/>
+          </a:ln>
+        </p:spPr>
+        <p:style>
+          <a:lnRef idx="1">
+            <a:schemeClr val="accent1"/>
+          </a:lnRef>
+          <a:fillRef idx="3">
+            <a:schemeClr val="accent1"/>
+          </a:fillRef>
+          <a:effectRef idx="2">
+            <a:schemeClr val="accent1"/>
+          </a:effectRef>
+          <a:fontRef idx="minor">
+            <a:schemeClr val="lt1"/>
+          </a:fontRef>
+        </p:style>
+        <p:txBody>
+          <a:bodyPr rtlCol="0" anchor="ctr"/>
+          <a:lstStyle/>
+          <a:p>
+            <a:pPr algn="ctr"/>
+          </a:p>
+        </p:txBody>
+      </p:sp>
+      <p:sp>
+        <p:nvSpPr>
+          <p:cNvPr id="27" name="TextBox 26"/>
+          <p:cNvSpPr txBox="1"/>
+          <p:nvPr/>
+        </p:nvSpPr>
+        <p:spPr>
+          <a:xfrm>
+            <a:off x="1600200" y="4059936"/>
+            <a:ext cx="1280160" cy="310896"/>
+          </a:xfrm>
+          <a:prstGeom prst="rect">
+            <a:avLst/>
+          </a:prstGeom>
+          <a:noFill/>
+        </p:spPr>
+        <p:txBody>
+          <a:bodyPr wrap="none">
+            <a:spAutoFit/>
+          </a:bodyPr>
+          <a:lstStyle/>
+          <a:p>
+            <a:pPr algn="ctr">
+              <a:spcAft>
+                <a:spcPts val="1000"/>
+              </a:spcAft>
+            </a:pPr>
+            <a:r>
+              <a:rPr sz="1800" b="1">
+                <a:solidFill>
+                  <a:srgbClr val="28462D"/>
+                </a:solidFill>
+                <a:latin typeface="Microsoft YaHei"/>
+              </a:rPr>
+              <a:t>结果</a:t>
+            </a:r>
+          </a:p>
+        </p:txBody>
+      </p:sp>
+      <p:sp>
+        <p:nvSpPr>
+          <p:cNvPr id="28" name="TextBox 27"/>
+          <p:cNvSpPr txBox="1"/>
+          <p:nvPr/>
+        </p:nvSpPr>
+        <p:spPr>
+          <a:xfrm>
+            <a:off x="3017520" y="4041648"/>
+            <a:ext cx="7498079" cy="658368"/>
+          </a:xfrm>
+          <a:prstGeom prst="rect">
+            <a:avLst/>
+          </a:prstGeom>
+          <a:noFill/>
+        </p:spPr>
+        <p:txBody>
+          <a:bodyPr wrap="none">
+            <a:spAutoFit/>
+          </a:bodyPr>
+          <a:lstStyle/>
+          <a:p>
+            <a:pPr algn="l">
+              <a:spcAft>
+                <a:spcPts val="1000"/>
+              </a:spcAft>
+            </a:pPr>
+            <a:r>
+              <a:rPr sz="2100" b="0">
+                <a:solidFill>
+                  <a:srgbClr val="28462D"/>
+                </a:solidFill>
+                <a:latin typeface="Microsoft YaHei"/>
+              </a:rPr>
+              <a:t>建立婚姻制度，让人类繁衍生息</a:t>
             </a:r>
           </a:p>
         </p:txBody>
@@ -4576,8 +5711,342 @@
         </p:nvSpPr>
         <p:spPr>
           <a:xfrm>
-            <a:off x="4953304" y="502920"/>
-            <a:ext cx="2286000" cy="411480"/>
+            <a:off x="502920" y="384048"/>
+            <a:ext cx="2011680" cy="384048"/>
+          </a:xfrm>
+          <a:prstGeom prst="roundRect">
+            <a:avLst/>
+          </a:prstGeom>
+          <a:solidFill>
+            <a:srgbClr val="468250"/>
+          </a:solidFill>
+          <a:ln>
+            <a:noFill/>
+          </a:ln>
+        </p:spPr>
+        <p:style>
+          <a:lnRef idx="1">
+            <a:schemeClr val="accent1"/>
+          </a:lnRef>
+          <a:fillRef idx="3">
+            <a:schemeClr val="accent1"/>
+          </a:fillRef>
+          <a:effectRef idx="2">
+            <a:schemeClr val="accent1"/>
+          </a:effectRef>
+          <a:fontRef idx="minor">
+            <a:schemeClr val="lt1"/>
+          </a:fontRef>
+        </p:style>
+        <p:txBody>
+          <a:bodyPr rtlCol="0" anchor="ctr"/>
+          <a:lstStyle/>
+          <a:p>
+            <a:pPr algn="ctr"/>
+          </a:p>
+        </p:txBody>
+      </p:sp>
+      <p:sp>
+        <p:nvSpPr>
+          <p:cNvPr id="7" name="TextBox 6"/>
+          <p:cNvSpPr txBox="1"/>
+          <p:nvPr/>
+        </p:nvSpPr>
+        <p:spPr>
+          <a:xfrm>
+            <a:off x="502920" y="402336"/>
+            <a:ext cx="2011680" cy="347472"/>
+          </a:xfrm>
+          <a:prstGeom prst="rect">
+            <a:avLst/>
+          </a:prstGeom>
+          <a:noFill/>
+        </p:spPr>
+        <p:txBody>
+          <a:bodyPr wrap="none">
+            <a:spAutoFit/>
+          </a:bodyPr>
+          <a:lstStyle/>
+          <a:p>
+            <a:pPr algn="ctr">
+              <a:spcAft>
+                <a:spcPts val="1000"/>
+              </a:spcAft>
+            </a:pPr>
+            <a:r>
+              <a:rPr sz="1600" b="1">
+                <a:solidFill>
+                  <a:srgbClr val="FFFFFF"/>
+                </a:solidFill>
+                <a:latin typeface="Microsoft YaHei"/>
+              </a:rPr>
+              <a:t>写法笔记</a:t>
+            </a:r>
+          </a:p>
+        </p:txBody>
+      </p:sp>
+      <p:sp>
+        <p:nvSpPr>
+          <p:cNvPr id="8" name="TextBox 7"/>
+          <p:cNvSpPr txBox="1"/>
+          <p:nvPr/>
+        </p:nvSpPr>
+        <p:spPr>
+          <a:xfrm>
+            <a:off x="1371600" y="384048"/>
+            <a:ext cx="9418320" cy="822960"/>
+          </a:xfrm>
+          <a:prstGeom prst="rect">
+            <a:avLst/>
+          </a:prstGeom>
+          <a:noFill/>
+        </p:spPr>
+        <p:txBody>
+          <a:bodyPr wrap="square">
+            <a:spAutoFit/>
+          </a:bodyPr>
+          <a:lstStyle/>
+          <a:p>
+            <a:pPr algn="ctr">
+              <a:spcAft>
+                <a:spcPts val="1000"/>
+              </a:spcAft>
+            </a:pPr>
+            <a:r>
+              <a:rPr sz="3400" b="1">
+                <a:solidFill>
+                  <a:srgbClr val="468250"/>
+                </a:solidFill>
+                <a:latin typeface="Microsoft YaHei"/>
+              </a:rPr>
+              <a:t>想象特点</a:t>
+            </a:r>
+          </a:p>
+        </p:txBody>
+      </p:sp>
+      <p:sp>
+        <p:nvSpPr>
+          <p:cNvPr id="9" name="Rounded Rectangle 8"/>
+          <p:cNvSpPr/>
+          <p:nvPr/>
+        </p:nvSpPr>
+        <p:spPr>
+          <a:xfrm>
+            <a:off x="1067104" y="1143000"/>
+            <a:ext cx="10058400" cy="3721608"/>
+          </a:xfrm>
+          <a:prstGeom prst="roundRect">
+            <a:avLst/>
+          </a:prstGeom>
+          <a:solidFill>
+            <a:srgbClr val="FFFCEB"/>
+          </a:solidFill>
+          <a:ln w="25400">
+            <a:solidFill>
+              <a:srgbClr val="5A8C5A"/>
+            </a:solidFill>
+          </a:ln>
+        </p:spPr>
+        <p:style>
+          <a:lnRef idx="1">
+            <a:schemeClr val="accent1"/>
+          </a:lnRef>
+          <a:fillRef idx="3">
+            <a:schemeClr val="accent1"/>
+          </a:fillRef>
+          <a:effectRef idx="2">
+            <a:schemeClr val="accent1"/>
+          </a:effectRef>
+          <a:fontRef idx="minor">
+            <a:schemeClr val="lt1"/>
+          </a:fontRef>
+        </p:style>
+        <p:txBody>
+          <a:bodyPr rtlCol="0" anchor="ctr"/>
+          <a:lstStyle/>
+          <a:p>
+            <a:pPr algn="ctr"/>
+          </a:p>
+        </p:txBody>
+      </p:sp>
+      <p:sp>
+        <p:nvSpPr>
+          <p:cNvPr id="10" name="Rectangle 9"/>
+          <p:cNvSpPr/>
+          <p:nvPr/>
+        </p:nvSpPr>
+        <p:spPr>
+          <a:xfrm>
+            <a:off x="1067104" y="1143000"/>
+            <a:ext cx="10058400" cy="384048"/>
+          </a:xfrm>
+          <a:prstGeom prst="rect">
+            <a:avLst/>
+          </a:prstGeom>
+          <a:solidFill>
+            <a:srgbClr val="468250"/>
+          </a:solidFill>
+          <a:ln>
+            <a:noFill/>
+          </a:ln>
+        </p:spPr>
+        <p:style>
+          <a:lnRef idx="1">
+            <a:schemeClr val="accent1"/>
+          </a:lnRef>
+          <a:fillRef idx="3">
+            <a:schemeClr val="accent1"/>
+          </a:fillRef>
+          <a:effectRef idx="2">
+            <a:schemeClr val="accent1"/>
+          </a:effectRef>
+          <a:fontRef idx="minor">
+            <a:schemeClr val="lt1"/>
+          </a:fontRef>
+        </p:style>
+        <p:txBody>
+          <a:bodyPr rtlCol="0" anchor="ctr"/>
+          <a:lstStyle/>
+          <a:p>
+            <a:pPr algn="ctr"/>
+          </a:p>
+        </p:txBody>
+      </p:sp>
+      <p:sp>
+        <p:nvSpPr>
+          <p:cNvPr id="11" name="TextBox 10"/>
+          <p:cNvSpPr txBox="1"/>
+          <p:nvPr/>
+        </p:nvSpPr>
+        <p:spPr>
+          <a:xfrm>
+            <a:off x="1067104" y="1179576"/>
+            <a:ext cx="10058400" cy="347472"/>
+          </a:xfrm>
+          <a:prstGeom prst="rect">
+            <a:avLst/>
+          </a:prstGeom>
+          <a:noFill/>
+        </p:spPr>
+        <p:txBody>
+          <a:bodyPr wrap="none">
+            <a:spAutoFit/>
+          </a:bodyPr>
+          <a:lstStyle/>
+          <a:p>
+            <a:pPr algn="ctr">
+              <a:spcAft>
+                <a:spcPts val="1000"/>
+              </a:spcAft>
+            </a:pPr>
+            <a:r>
+              <a:rPr sz="1800" b="1">
+                <a:solidFill>
+                  <a:srgbClr val="FFFFFF"/>
+                </a:solidFill>
+                <a:latin typeface="Microsoft YaHei"/>
+              </a:rPr>
+              <a:t>📝  课堂笔记  —  请摘抄要点</a:t>
+            </a:r>
+          </a:p>
+        </p:txBody>
+      </p:sp>
+      <p:sp>
+        <p:nvSpPr>
+          <p:cNvPr id="12" name="Rectangle 11"/>
+          <p:cNvSpPr/>
+          <p:nvPr/>
+        </p:nvSpPr>
+        <p:spPr>
+          <a:xfrm>
+            <a:off x="1570024" y="1527048"/>
+            <a:ext cx="27432" cy="3337560"/>
+          </a:xfrm>
+          <a:prstGeom prst="rect">
+            <a:avLst/>
+          </a:prstGeom>
+          <a:solidFill>
+            <a:srgbClr val="DC5050"/>
+          </a:solidFill>
+          <a:ln>
+            <a:noFill/>
+          </a:ln>
+        </p:spPr>
+        <p:style>
+          <a:lnRef idx="1">
+            <a:schemeClr val="accent1"/>
+          </a:lnRef>
+          <a:fillRef idx="3">
+            <a:schemeClr val="accent1"/>
+          </a:fillRef>
+          <a:effectRef idx="2">
+            <a:schemeClr val="accent1"/>
+          </a:effectRef>
+          <a:fontRef idx="minor">
+            <a:schemeClr val="lt1"/>
+          </a:fontRef>
+        </p:style>
+        <p:txBody>
+          <a:bodyPr rtlCol="0" anchor="ctr"/>
+          <a:lstStyle/>
+          <a:p>
+            <a:pPr algn="ctr"/>
+          </a:p>
+        </p:txBody>
+      </p:sp>
+      <p:sp>
+        <p:nvSpPr>
+          <p:cNvPr id="13" name="Rectangle 12"/>
+          <p:cNvSpPr/>
+          <p:nvPr/>
+        </p:nvSpPr>
+        <p:spPr>
+          <a:xfrm>
+            <a:off x="1417320" y="2276856"/>
+            <a:ext cx="9601200" cy="13716"/>
+          </a:xfrm>
+          <a:prstGeom prst="rect">
+            <a:avLst/>
+          </a:prstGeom>
+          <a:solidFill>
+            <a:srgbClr val="D2C8AF"/>
+          </a:solidFill>
+          <a:ln>
+            <a:noFill/>
+          </a:ln>
+        </p:spPr>
+        <p:style>
+          <a:lnRef idx="1">
+            <a:schemeClr val="accent1"/>
+          </a:lnRef>
+          <a:fillRef idx="3">
+            <a:schemeClr val="accent1"/>
+          </a:fillRef>
+          <a:effectRef idx="2">
+            <a:schemeClr val="accent1"/>
+          </a:effectRef>
+          <a:fontRef idx="minor">
+            <a:schemeClr val="lt1"/>
+          </a:fontRef>
+        </p:style>
+        <p:txBody>
+          <a:bodyPr rtlCol="0" anchor="ctr"/>
+          <a:lstStyle/>
+          <a:p>
+            <a:pPr algn="ctr"/>
+          </a:p>
+        </p:txBody>
+      </p:sp>
+      <p:sp>
+        <p:nvSpPr>
+          <p:cNvPr id="14" name="Rounded Rectangle 13"/>
+          <p:cNvSpPr/>
+          <p:nvPr/>
+        </p:nvSpPr>
+        <p:spPr>
+          <a:xfrm>
+            <a:off x="1600200" y="1627632"/>
+            <a:ext cx="1280160" cy="347472"/>
           </a:xfrm>
           <a:prstGeom prst="roundRect">
             <a:avLst/>
@@ -4613,14 +6082,14 @@
       </p:sp>
       <p:sp>
         <p:nvSpPr>
-          <p:cNvPr id="7" name="TextBox 6"/>
+          <p:cNvPr id="15" name="TextBox 14"/>
           <p:cNvSpPr txBox="1"/>
           <p:nvPr/>
         </p:nvSpPr>
         <p:spPr>
           <a:xfrm>
-            <a:off x="4953304" y="521208"/>
-            <a:ext cx="2286000" cy="384048"/>
+            <a:off x="1600200" y="1645920"/>
+            <a:ext cx="1280160" cy="310896"/>
           </a:xfrm>
           <a:prstGeom prst="rect">
             <a:avLst/>
@@ -4645,21 +6114,21 @@
                 </a:solidFill>
                 <a:latin typeface="Microsoft YaHei"/>
               </a:rPr>
-              <a:t>追踪创造</a:t>
-            </a:r>
-          </a:p>
-        </p:txBody>
-      </p:sp>
-      <p:sp>
-        <p:nvSpPr>
-          <p:cNvPr id="8" name="TextBox 7"/>
+              <a:t>具体</a:t>
+            </a:r>
+          </a:p>
+        </p:txBody>
+      </p:sp>
+      <p:sp>
+        <p:nvSpPr>
+          <p:cNvPr id="16" name="TextBox 15"/>
           <p:cNvSpPr txBox="1"/>
           <p:nvPr/>
         </p:nvSpPr>
         <p:spPr>
           <a:xfrm>
-            <a:off x="1371600" y="960120"/>
-            <a:ext cx="9418320" cy="822960"/>
+            <a:off x="3017520" y="1627632"/>
+            <a:ext cx="7498079" cy="658368"/>
           </a:xfrm>
           <a:prstGeom prst="rect">
             <a:avLst/>
@@ -4667,40 +6136,83 @@
           <a:noFill/>
         </p:spPr>
         <p:txBody>
-          <a:bodyPr wrap="square">
+          <a:bodyPr wrap="none">
             <a:spAutoFit/>
           </a:bodyPr>
           <a:lstStyle/>
           <a:p>
-            <a:pPr algn="ctr">
+            <a:pPr algn="l">
               <a:spcAft>
                 <a:spcPts val="1000"/>
               </a:spcAft>
             </a:pPr>
             <a:r>
-              <a:rPr sz="3600" b="1">
+              <a:rPr sz="2100" b="0">
                 <a:solidFill>
-                  <a:srgbClr val="468250"/>
+                  <a:srgbClr val="28462D"/>
                 </a:solidFill>
                 <a:latin typeface="Microsoft YaHei"/>
               </a:rPr>
-              <a:t>学习任务一</a:t>
-            </a:r>
-          </a:p>
-        </p:txBody>
-      </p:sp>
-      <p:sp>
-        <p:nvSpPr>
-          <p:cNvPr id="9" name="Rectangle 8"/>
+              <a:t>池水照影见自己面容→想到造同类</a:t>
+            </a:r>
+          </a:p>
+        </p:txBody>
+      </p:sp>
+      <p:sp>
+        <p:nvSpPr>
+          <p:cNvPr id="17" name="Rectangle 16"/>
           <p:cNvSpPr/>
           <p:nvPr/>
         </p:nvSpPr>
         <p:spPr>
           <a:xfrm>
-            <a:off x="3200400" y="1600200"/>
-            <a:ext cx="5760720" cy="27432"/>
-          </a:xfrm>
-          <a:prstGeom prst="rect">
+            <a:off x="1417320" y="3081527"/>
+            <a:ext cx="9601200" cy="13716"/>
+          </a:xfrm>
+          <a:prstGeom prst="rect">
+            <a:avLst/>
+          </a:prstGeom>
+          <a:solidFill>
+            <a:srgbClr val="D2C8AF"/>
+          </a:solidFill>
+          <a:ln>
+            <a:noFill/>
+          </a:ln>
+        </p:spPr>
+        <p:style>
+          <a:lnRef idx="1">
+            <a:schemeClr val="accent1"/>
+          </a:lnRef>
+          <a:fillRef idx="3">
+            <a:schemeClr val="accent1"/>
+          </a:fillRef>
+          <a:effectRef idx="2">
+            <a:schemeClr val="accent1"/>
+          </a:effectRef>
+          <a:fontRef idx="minor">
+            <a:schemeClr val="lt1"/>
+          </a:fontRef>
+        </p:style>
+        <p:txBody>
+          <a:bodyPr rtlCol="0" anchor="ctr"/>
+          <a:lstStyle/>
+          <a:p>
+            <a:pPr algn="ctr"/>
+          </a:p>
+        </p:txBody>
+      </p:sp>
+      <p:sp>
+        <p:nvSpPr>
+          <p:cNvPr id="18" name="Rounded Rectangle 17"/>
+          <p:cNvSpPr/>
+          <p:nvPr/>
+        </p:nvSpPr>
+        <p:spPr>
+          <a:xfrm>
+            <a:off x="1600200" y="2432303"/>
+            <a:ext cx="1280160" cy="347472"/>
+          </a:xfrm>
+          <a:prstGeom prst="roundRect">
             <a:avLst/>
           </a:prstGeom>
           <a:solidFill>
@@ -4734,25 +6246,101 @@
       </p:sp>
       <p:sp>
         <p:nvSpPr>
-          <p:cNvPr id="10" name="Rounded Rectangle 9"/>
+          <p:cNvPr id="19" name="TextBox 18"/>
+          <p:cNvSpPr txBox="1"/>
+          <p:nvPr/>
+        </p:nvSpPr>
+        <p:spPr>
+          <a:xfrm>
+            <a:off x="1600200" y="2450591"/>
+            <a:ext cx="1280160" cy="310896"/>
+          </a:xfrm>
+          <a:prstGeom prst="rect">
+            <a:avLst/>
+          </a:prstGeom>
+          <a:noFill/>
+        </p:spPr>
+        <p:txBody>
+          <a:bodyPr wrap="none">
+            <a:spAutoFit/>
+          </a:bodyPr>
+          <a:lstStyle/>
+          <a:p>
+            <a:pPr algn="ctr">
+              <a:spcAft>
+                <a:spcPts val="1000"/>
+              </a:spcAft>
+            </a:pPr>
+            <a:r>
+              <a:rPr sz="1800" b="1">
+                <a:solidFill>
+                  <a:srgbClr val="28462D"/>
+                </a:solidFill>
+                <a:latin typeface="Microsoft YaHei"/>
+              </a:rPr>
+              <a:t>生动</a:t>
+            </a:r>
+          </a:p>
+        </p:txBody>
+      </p:sp>
+      <p:sp>
+        <p:nvSpPr>
+          <p:cNvPr id="20" name="TextBox 19"/>
+          <p:cNvSpPr txBox="1"/>
+          <p:nvPr/>
+        </p:nvSpPr>
+        <p:spPr>
+          <a:xfrm>
+            <a:off x="3017520" y="2432303"/>
+            <a:ext cx="7498079" cy="658368"/>
+          </a:xfrm>
+          <a:prstGeom prst="rect">
+            <a:avLst/>
+          </a:prstGeom>
+          <a:noFill/>
+        </p:spPr>
+        <p:txBody>
+          <a:bodyPr wrap="none">
+            <a:spAutoFit/>
+          </a:bodyPr>
+          <a:lstStyle/>
+          <a:p>
+            <a:pPr algn="l">
+              <a:spcAft>
+                <a:spcPts val="1000"/>
+              </a:spcAft>
+            </a:pPr>
+            <a:r>
+              <a:rPr sz="2100" b="0">
+                <a:solidFill>
+                  <a:srgbClr val="28462D"/>
+                </a:solidFill>
+                <a:latin typeface="Microsoft YaHei"/>
+              </a:rPr>
+              <a:t>「藤条一挥，满天泥浆洒落」画面感强</a:t>
+            </a:r>
+          </a:p>
+        </p:txBody>
+      </p:sp>
+      <p:sp>
+        <p:nvSpPr>
+          <p:cNvPr id="21" name="Rectangle 20"/>
           <p:cNvSpPr/>
           <p:nvPr/>
         </p:nvSpPr>
         <p:spPr>
           <a:xfrm>
-            <a:off x="1295704" y="1645920"/>
-            <a:ext cx="9601200" cy="2240280"/>
-          </a:xfrm>
-          <a:prstGeom prst="roundRect">
+            <a:off x="1417320" y="3886200"/>
+            <a:ext cx="9601200" cy="13716"/>
+          </a:xfrm>
+          <a:prstGeom prst="rect">
             <a:avLst/>
           </a:prstGeom>
           <a:solidFill>
-            <a:srgbClr val="F8FCF5"/>
+            <a:srgbClr val="D2C8AF"/>
           </a:solidFill>
-          <a:ln w="19050">
-            <a:solidFill>
-              <a:srgbClr val="A0C896"/>
-            </a:solidFill>
+          <a:ln>
+            <a:noFill/>
           </a:ln>
         </p:spPr>
         <p:style>
@@ -4779,20 +6367,20 @@
       </p:sp>
       <p:sp>
         <p:nvSpPr>
-          <p:cNvPr id="11" name="Oval 10"/>
+          <p:cNvPr id="22" name="Rounded Rectangle 21"/>
           <p:cNvSpPr/>
           <p:nvPr/>
         </p:nvSpPr>
         <p:spPr>
           <a:xfrm>
-            <a:off x="2255824" y="1828800"/>
-            <a:ext cx="384048" cy="384048"/>
-          </a:xfrm>
-          <a:prstGeom prst="ellipse">
+            <a:off x="1600200" y="3236976"/>
+            <a:ext cx="1280160" cy="347472"/>
+          </a:xfrm>
+          <a:prstGeom prst="roundRect">
             <a:avLst/>
           </a:prstGeom>
           <a:solidFill>
-            <a:srgbClr val="468250"/>
+            <a:srgbClr val="A0C896"/>
           </a:solidFill>
           <a:ln>
             <a:noFill/>
@@ -4822,14 +6410,14 @@
       </p:sp>
       <p:sp>
         <p:nvSpPr>
-          <p:cNvPr id="12" name="TextBox 11"/>
+          <p:cNvPr id="23" name="TextBox 22"/>
           <p:cNvSpPr txBox="1"/>
           <p:nvPr/>
         </p:nvSpPr>
         <p:spPr>
           <a:xfrm>
-            <a:off x="2255824" y="1847088"/>
-            <a:ext cx="384048" cy="365760"/>
+            <a:off x="1600200" y="3255264"/>
+            <a:ext cx="1280160" cy="310896"/>
           </a:xfrm>
           <a:prstGeom prst="rect">
             <a:avLst/>
@@ -4848,27 +6436,27 @@
               </a:spcAft>
             </a:pPr>
             <a:r>
-              <a:rPr sz="1600" b="1">
+              <a:rPr sz="1800" b="1">
                 <a:solidFill>
-                  <a:srgbClr val="FFFFFF"/>
+                  <a:srgbClr val="28462D"/>
                 </a:solidFill>
                 <a:latin typeface="Microsoft YaHei"/>
               </a:rPr>
-              <a:t>1</a:t>
-            </a:r>
-          </a:p>
-        </p:txBody>
-      </p:sp>
-      <p:sp>
-        <p:nvSpPr>
-          <p:cNvPr id="13" name="TextBox 12"/>
+              <a:t>温暖</a:t>
+            </a:r>
+          </a:p>
+        </p:txBody>
+      </p:sp>
+      <p:sp>
+        <p:nvSpPr>
+          <p:cNvPr id="24" name="TextBox 23"/>
           <p:cNvSpPr txBox="1"/>
           <p:nvPr/>
         </p:nvSpPr>
         <p:spPr>
           <a:xfrm>
-            <a:off x="2758744" y="1810512"/>
-            <a:ext cx="7772400" cy="502920"/>
+            <a:off x="3017520" y="3236976"/>
+            <a:ext cx="7498079" cy="658368"/>
           </a:xfrm>
           <a:prstGeom prst="rect">
             <a:avLst/>
@@ -4887,33 +6475,33 @@
               </a:spcAft>
             </a:pPr>
             <a:r>
-              <a:rPr sz="2400" b="0">
+              <a:rPr sz="2100" b="0">
                 <a:solidFill>
                   <a:srgbClr val="28462D"/>
                 </a:solidFill>
                 <a:latin typeface="Microsoft YaHei"/>
               </a:rPr>
-              <a:t>给女娲行动排序：孤独→揉泥→挥洒→繁衍</a:t>
-            </a:r>
-          </a:p>
-        </p:txBody>
-      </p:sp>
-      <p:sp>
-        <p:nvSpPr>
-          <p:cNvPr id="14" name="Oval 13"/>
+              <a:t>造人后的疲倦、喜悦，赋予神以人的情感</a:t>
+            </a:r>
+          </a:p>
+        </p:txBody>
+      </p:sp>
+      <p:sp>
+        <p:nvSpPr>
+          <p:cNvPr id="25" name="Rectangle 24"/>
           <p:cNvSpPr/>
           <p:nvPr/>
         </p:nvSpPr>
         <p:spPr>
           <a:xfrm>
-            <a:off x="2255824" y="2395728"/>
-            <a:ext cx="384048" cy="384048"/>
-          </a:xfrm>
-          <a:prstGeom prst="ellipse">
+            <a:off x="1417320" y="4690872"/>
+            <a:ext cx="9601200" cy="13716"/>
+          </a:xfrm>
+          <a:prstGeom prst="rect">
             <a:avLst/>
           </a:prstGeom>
           <a:solidFill>
-            <a:srgbClr val="468250"/>
+            <a:srgbClr val="D2C8AF"/>
           </a:solidFill>
           <a:ln>
             <a:noFill/>
@@ -4943,14 +6531,57 @@
       </p:sp>
       <p:sp>
         <p:nvSpPr>
-          <p:cNvPr id="15" name="TextBox 14"/>
+          <p:cNvPr id="26" name="Rounded Rectangle 25"/>
+          <p:cNvSpPr/>
+          <p:nvPr/>
+        </p:nvSpPr>
+        <p:spPr>
+          <a:xfrm>
+            <a:off x="1600200" y="4041648"/>
+            <a:ext cx="1280160" cy="347472"/>
+          </a:xfrm>
+          <a:prstGeom prst="roundRect">
+            <a:avLst/>
+          </a:prstGeom>
+          <a:solidFill>
+            <a:srgbClr val="A0C896"/>
+          </a:solidFill>
+          <a:ln>
+            <a:noFill/>
+          </a:ln>
+        </p:spPr>
+        <p:style>
+          <a:lnRef idx="1">
+            <a:schemeClr val="accent1"/>
+          </a:lnRef>
+          <a:fillRef idx="3">
+            <a:schemeClr val="accent1"/>
+          </a:fillRef>
+          <a:effectRef idx="2">
+            <a:schemeClr val="accent1"/>
+          </a:effectRef>
+          <a:fontRef idx="minor">
+            <a:schemeClr val="lt1"/>
+          </a:fontRef>
+        </p:style>
+        <p:txBody>
+          <a:bodyPr rtlCol="0" anchor="ctr"/>
+          <a:lstStyle/>
+          <a:p>
+            <a:pPr algn="ctr"/>
+          </a:p>
+        </p:txBody>
+      </p:sp>
+      <p:sp>
+        <p:nvSpPr>
+          <p:cNvPr id="27" name="TextBox 26"/>
           <p:cNvSpPr txBox="1"/>
           <p:nvPr/>
         </p:nvSpPr>
         <p:spPr>
           <a:xfrm>
-            <a:off x="2255824" y="2414016"/>
-            <a:ext cx="384048" cy="365760"/>
+            <a:off x="1600200" y="4059936"/>
+            <a:ext cx="1280160" cy="310896"/>
           </a:xfrm>
           <a:prstGeom prst="rect">
             <a:avLst/>
@@ -4969,27 +6600,27 @@
               </a:spcAft>
             </a:pPr>
             <a:r>
-              <a:rPr sz="1600" b="1">
+              <a:rPr sz="1800" b="1">
                 <a:solidFill>
-                  <a:srgbClr val="FFFFFF"/>
+                  <a:srgbClr val="28462D"/>
                 </a:solidFill>
                 <a:latin typeface="Microsoft YaHei"/>
               </a:rPr>
-              <a:t>2</a:t>
-            </a:r>
-          </a:p>
-        </p:txBody>
-      </p:sp>
-      <p:sp>
-        <p:nvSpPr>
-          <p:cNvPr id="16" name="TextBox 15"/>
+              <a:t>规律</a:t>
+            </a:r>
+          </a:p>
+        </p:txBody>
+      </p:sp>
+      <p:sp>
+        <p:nvSpPr>
+          <p:cNvPr id="28" name="TextBox 27"/>
           <p:cNvSpPr txBox="1"/>
           <p:nvPr/>
         </p:nvSpPr>
         <p:spPr>
           <a:xfrm>
-            <a:off x="2758744" y="2377440"/>
-            <a:ext cx="7772400" cy="502920"/>
+            <a:off x="3017520" y="4041648"/>
+            <a:ext cx="7498079" cy="658368"/>
           </a:xfrm>
           <a:prstGeom prst="rect">
             <a:avLst/>
@@ -5008,134 +6639,13 @@
               </a:spcAft>
             </a:pPr>
             <a:r>
-              <a:rPr sz="2400" b="0">
+              <a:rPr sz="2100" b="0">
                 <a:solidFill>
                   <a:srgbClr val="28462D"/>
                 </a:solidFill>
                 <a:latin typeface="Microsoft YaHei"/>
               </a:rPr>
-              <a:t>比较两种造人方法的不同</a:t>
-            </a:r>
-          </a:p>
-        </p:txBody>
-      </p:sp>
-      <p:sp>
-        <p:nvSpPr>
-          <p:cNvPr id="17" name="Oval 16"/>
-          <p:cNvSpPr/>
-          <p:nvPr/>
-        </p:nvSpPr>
-        <p:spPr>
-          <a:xfrm>
-            <a:off x="2255824" y="2962656"/>
-            <a:ext cx="384048" cy="384048"/>
-          </a:xfrm>
-          <a:prstGeom prst="ellipse">
-            <a:avLst/>
-          </a:prstGeom>
-          <a:solidFill>
-            <a:srgbClr val="468250"/>
-          </a:solidFill>
-          <a:ln>
-            <a:noFill/>
-          </a:ln>
-        </p:spPr>
-        <p:style>
-          <a:lnRef idx="1">
-            <a:schemeClr val="accent1"/>
-          </a:lnRef>
-          <a:fillRef idx="3">
-            <a:schemeClr val="accent1"/>
-          </a:fillRef>
-          <a:effectRef idx="2">
-            <a:schemeClr val="accent1"/>
-          </a:effectRef>
-          <a:fontRef idx="minor">
-            <a:schemeClr val="lt1"/>
-          </a:fontRef>
-        </p:style>
-        <p:txBody>
-          <a:bodyPr rtlCol="0" anchor="ctr"/>
-          <a:lstStyle/>
-          <a:p>
-            <a:pPr algn="ctr"/>
-          </a:p>
-        </p:txBody>
-      </p:sp>
-      <p:sp>
-        <p:nvSpPr>
-          <p:cNvPr id="18" name="TextBox 17"/>
-          <p:cNvSpPr txBox="1"/>
-          <p:nvPr/>
-        </p:nvSpPr>
-        <p:spPr>
-          <a:xfrm>
-            <a:off x="2255824" y="2980944"/>
-            <a:ext cx="384048" cy="365760"/>
-          </a:xfrm>
-          <a:prstGeom prst="rect">
-            <a:avLst/>
-          </a:prstGeom>
-          <a:noFill/>
-        </p:spPr>
-        <p:txBody>
-          <a:bodyPr wrap="none">
-            <a:spAutoFit/>
-          </a:bodyPr>
-          <a:lstStyle/>
-          <a:p>
-            <a:pPr algn="ctr">
-              <a:spcAft>
-                <a:spcPts val="1000"/>
-              </a:spcAft>
-            </a:pPr>
-            <a:r>
-              <a:rPr sz="1600" b="1">
-                <a:solidFill>
-                  <a:srgbClr val="FFFFFF"/>
-                </a:solidFill>
-                <a:latin typeface="Microsoft YaHei"/>
-              </a:rPr>
-              <a:t>3</a:t>
-            </a:r>
-          </a:p>
-        </p:txBody>
-      </p:sp>
-      <p:sp>
-        <p:nvSpPr>
-          <p:cNvPr id="19" name="TextBox 18"/>
-          <p:cNvSpPr txBox="1"/>
-          <p:nvPr/>
-        </p:nvSpPr>
-        <p:spPr>
-          <a:xfrm>
-            <a:off x="2758744" y="2944368"/>
-            <a:ext cx="7772400" cy="502920"/>
-          </a:xfrm>
-          <a:prstGeom prst="rect">
-            <a:avLst/>
-          </a:prstGeom>
-          <a:noFill/>
-        </p:spPr>
-        <p:txBody>
-          <a:bodyPr wrap="none">
-            <a:spAutoFit/>
-          </a:bodyPr>
-          <a:lstStyle/>
-          <a:p>
-            <a:pPr algn="l">
-              <a:spcAft>
-                <a:spcPts val="1000"/>
-              </a:spcAft>
-            </a:pPr>
-            <a:r>
-              <a:rPr sz="2400" b="0">
-                <a:solidFill>
-                  <a:srgbClr val="28462D"/>
-                </a:solidFill>
-                <a:latin typeface="Microsoft YaHei"/>
-              </a:rPr>
-              <a:t>复述：从孤独到热闹的过程</a:t>
+              <a:t>想象基于生活经验（和泥、洒水），又超越现实</a:t>
             </a:r>
           </a:p>
         </p:txBody>
@@ -5281,8 +6791,342 @@
         </p:nvSpPr>
         <p:spPr>
           <a:xfrm>
-            <a:off x="4953304" y="502920"/>
-            <a:ext cx="2286000" cy="411480"/>
+            <a:off x="502920" y="384048"/>
+            <a:ext cx="2011680" cy="384048"/>
+          </a:xfrm>
+          <a:prstGeom prst="roundRect">
+            <a:avLst/>
+          </a:prstGeom>
+          <a:solidFill>
+            <a:srgbClr val="468250"/>
+          </a:solidFill>
+          <a:ln>
+            <a:noFill/>
+          </a:ln>
+        </p:spPr>
+        <p:style>
+          <a:lnRef idx="1">
+            <a:schemeClr val="accent1"/>
+          </a:lnRef>
+          <a:fillRef idx="3">
+            <a:schemeClr val="accent1"/>
+          </a:fillRef>
+          <a:effectRef idx="2">
+            <a:schemeClr val="accent1"/>
+          </a:effectRef>
+          <a:fontRef idx="minor">
+            <a:schemeClr val="lt1"/>
+          </a:fontRef>
+        </p:style>
+        <p:txBody>
+          <a:bodyPr rtlCol="0" anchor="ctr"/>
+          <a:lstStyle/>
+          <a:p>
+            <a:pPr algn="ctr"/>
+          </a:p>
+        </p:txBody>
+      </p:sp>
+      <p:sp>
+        <p:nvSpPr>
+          <p:cNvPr id="7" name="TextBox 6"/>
+          <p:cNvSpPr txBox="1"/>
+          <p:nvPr/>
+        </p:nvSpPr>
+        <p:spPr>
+          <a:xfrm>
+            <a:off x="502920" y="402336"/>
+            <a:ext cx="2011680" cy="347472"/>
+          </a:xfrm>
+          <a:prstGeom prst="rect">
+            <a:avLst/>
+          </a:prstGeom>
+          <a:noFill/>
+        </p:spPr>
+        <p:txBody>
+          <a:bodyPr wrap="none">
+            <a:spAutoFit/>
+          </a:bodyPr>
+          <a:lstStyle/>
+          <a:p>
+            <a:pPr algn="ctr">
+              <a:spcAft>
+                <a:spcPts val="1000"/>
+              </a:spcAft>
+            </a:pPr>
+            <a:r>
+              <a:rPr sz="1600" b="1">
+                <a:solidFill>
+                  <a:srgbClr val="FFFFFF"/>
+                </a:solidFill>
+                <a:latin typeface="Microsoft YaHei"/>
+              </a:rPr>
+              <a:t>主题笔记</a:t>
+            </a:r>
+          </a:p>
+        </p:txBody>
+      </p:sp>
+      <p:sp>
+        <p:nvSpPr>
+          <p:cNvPr id="8" name="TextBox 7"/>
+          <p:cNvSpPr txBox="1"/>
+          <p:nvPr/>
+        </p:nvSpPr>
+        <p:spPr>
+          <a:xfrm>
+            <a:off x="1371600" y="384048"/>
+            <a:ext cx="9418320" cy="822960"/>
+          </a:xfrm>
+          <a:prstGeom prst="rect">
+            <a:avLst/>
+          </a:prstGeom>
+          <a:noFill/>
+        </p:spPr>
+        <p:txBody>
+          <a:bodyPr wrap="square">
+            <a:spAutoFit/>
+          </a:bodyPr>
+          <a:lstStyle/>
+          <a:p>
+            <a:pPr algn="ctr">
+              <a:spcAft>
+                <a:spcPts val="1000"/>
+              </a:spcAft>
+            </a:pPr>
+            <a:r>
+              <a:rPr sz="3400" b="1">
+                <a:solidFill>
+                  <a:srgbClr val="468250"/>
+                </a:solidFill>
+                <a:latin typeface="Microsoft YaHei"/>
+              </a:rPr>
+              <a:t>比较阅读</a:t>
+            </a:r>
+          </a:p>
+        </p:txBody>
+      </p:sp>
+      <p:sp>
+        <p:nvSpPr>
+          <p:cNvPr id="9" name="Rounded Rectangle 8"/>
+          <p:cNvSpPr/>
+          <p:nvPr/>
+        </p:nvSpPr>
+        <p:spPr>
+          <a:xfrm>
+            <a:off x="1067104" y="1143000"/>
+            <a:ext cx="10058400" cy="3721608"/>
+          </a:xfrm>
+          <a:prstGeom prst="roundRect">
+            <a:avLst/>
+          </a:prstGeom>
+          <a:solidFill>
+            <a:srgbClr val="FFFCEB"/>
+          </a:solidFill>
+          <a:ln w="25400">
+            <a:solidFill>
+              <a:srgbClr val="5A8C5A"/>
+            </a:solidFill>
+          </a:ln>
+        </p:spPr>
+        <p:style>
+          <a:lnRef idx="1">
+            <a:schemeClr val="accent1"/>
+          </a:lnRef>
+          <a:fillRef idx="3">
+            <a:schemeClr val="accent1"/>
+          </a:fillRef>
+          <a:effectRef idx="2">
+            <a:schemeClr val="accent1"/>
+          </a:effectRef>
+          <a:fontRef idx="minor">
+            <a:schemeClr val="lt1"/>
+          </a:fontRef>
+        </p:style>
+        <p:txBody>
+          <a:bodyPr rtlCol="0" anchor="ctr"/>
+          <a:lstStyle/>
+          <a:p>
+            <a:pPr algn="ctr"/>
+          </a:p>
+        </p:txBody>
+      </p:sp>
+      <p:sp>
+        <p:nvSpPr>
+          <p:cNvPr id="10" name="Rectangle 9"/>
+          <p:cNvSpPr/>
+          <p:nvPr/>
+        </p:nvSpPr>
+        <p:spPr>
+          <a:xfrm>
+            <a:off x="1067104" y="1143000"/>
+            <a:ext cx="10058400" cy="384048"/>
+          </a:xfrm>
+          <a:prstGeom prst="rect">
+            <a:avLst/>
+          </a:prstGeom>
+          <a:solidFill>
+            <a:srgbClr val="468250"/>
+          </a:solidFill>
+          <a:ln>
+            <a:noFill/>
+          </a:ln>
+        </p:spPr>
+        <p:style>
+          <a:lnRef idx="1">
+            <a:schemeClr val="accent1"/>
+          </a:lnRef>
+          <a:fillRef idx="3">
+            <a:schemeClr val="accent1"/>
+          </a:fillRef>
+          <a:effectRef idx="2">
+            <a:schemeClr val="accent1"/>
+          </a:effectRef>
+          <a:fontRef idx="minor">
+            <a:schemeClr val="lt1"/>
+          </a:fontRef>
+        </p:style>
+        <p:txBody>
+          <a:bodyPr rtlCol="0" anchor="ctr"/>
+          <a:lstStyle/>
+          <a:p>
+            <a:pPr algn="ctr"/>
+          </a:p>
+        </p:txBody>
+      </p:sp>
+      <p:sp>
+        <p:nvSpPr>
+          <p:cNvPr id="11" name="TextBox 10"/>
+          <p:cNvSpPr txBox="1"/>
+          <p:nvPr/>
+        </p:nvSpPr>
+        <p:spPr>
+          <a:xfrm>
+            <a:off x="1067104" y="1179576"/>
+            <a:ext cx="10058400" cy="347472"/>
+          </a:xfrm>
+          <a:prstGeom prst="rect">
+            <a:avLst/>
+          </a:prstGeom>
+          <a:noFill/>
+        </p:spPr>
+        <p:txBody>
+          <a:bodyPr wrap="none">
+            <a:spAutoFit/>
+          </a:bodyPr>
+          <a:lstStyle/>
+          <a:p>
+            <a:pPr algn="ctr">
+              <a:spcAft>
+                <a:spcPts val="1000"/>
+              </a:spcAft>
+            </a:pPr>
+            <a:r>
+              <a:rPr sz="1800" b="1">
+                <a:solidFill>
+                  <a:srgbClr val="FFFFFF"/>
+                </a:solidFill>
+                <a:latin typeface="Microsoft YaHei"/>
+              </a:rPr>
+              <a:t>📝  课堂笔记  —  请摘抄要点</a:t>
+            </a:r>
+          </a:p>
+        </p:txBody>
+      </p:sp>
+      <p:sp>
+        <p:nvSpPr>
+          <p:cNvPr id="12" name="Rectangle 11"/>
+          <p:cNvSpPr/>
+          <p:nvPr/>
+        </p:nvSpPr>
+        <p:spPr>
+          <a:xfrm>
+            <a:off x="1570024" y="1527048"/>
+            <a:ext cx="27432" cy="3337560"/>
+          </a:xfrm>
+          <a:prstGeom prst="rect">
+            <a:avLst/>
+          </a:prstGeom>
+          <a:solidFill>
+            <a:srgbClr val="DC5050"/>
+          </a:solidFill>
+          <a:ln>
+            <a:noFill/>
+          </a:ln>
+        </p:spPr>
+        <p:style>
+          <a:lnRef idx="1">
+            <a:schemeClr val="accent1"/>
+          </a:lnRef>
+          <a:fillRef idx="3">
+            <a:schemeClr val="accent1"/>
+          </a:fillRef>
+          <a:effectRef idx="2">
+            <a:schemeClr val="accent1"/>
+          </a:effectRef>
+          <a:fontRef idx="minor">
+            <a:schemeClr val="lt1"/>
+          </a:fontRef>
+        </p:style>
+        <p:txBody>
+          <a:bodyPr rtlCol="0" anchor="ctr"/>
+          <a:lstStyle/>
+          <a:p>
+            <a:pPr algn="ctr"/>
+          </a:p>
+        </p:txBody>
+      </p:sp>
+      <p:sp>
+        <p:nvSpPr>
+          <p:cNvPr id="13" name="Rectangle 12"/>
+          <p:cNvSpPr/>
+          <p:nvPr/>
+        </p:nvSpPr>
+        <p:spPr>
+          <a:xfrm>
+            <a:off x="1417320" y="2276856"/>
+            <a:ext cx="9601200" cy="13716"/>
+          </a:xfrm>
+          <a:prstGeom prst="rect">
+            <a:avLst/>
+          </a:prstGeom>
+          <a:solidFill>
+            <a:srgbClr val="D2C8AF"/>
+          </a:solidFill>
+          <a:ln>
+            <a:noFill/>
+          </a:ln>
+        </p:spPr>
+        <p:style>
+          <a:lnRef idx="1">
+            <a:schemeClr val="accent1"/>
+          </a:lnRef>
+          <a:fillRef idx="3">
+            <a:schemeClr val="accent1"/>
+          </a:fillRef>
+          <a:effectRef idx="2">
+            <a:schemeClr val="accent1"/>
+          </a:effectRef>
+          <a:fontRef idx="minor">
+            <a:schemeClr val="lt1"/>
+          </a:fontRef>
+        </p:style>
+        <p:txBody>
+          <a:bodyPr rtlCol="0" anchor="ctr"/>
+          <a:lstStyle/>
+          <a:p>
+            <a:pPr algn="ctr"/>
+          </a:p>
+        </p:txBody>
+      </p:sp>
+      <p:sp>
+        <p:nvSpPr>
+          <p:cNvPr id="14" name="Rounded Rectangle 13"/>
+          <p:cNvSpPr/>
+          <p:nvPr/>
+        </p:nvSpPr>
+        <p:spPr>
+          <a:xfrm>
+            <a:off x="1600200" y="1627632"/>
+            <a:ext cx="1737360" cy="347472"/>
           </a:xfrm>
           <a:prstGeom prst="roundRect">
             <a:avLst/>
@@ -5318,14 +7162,14 @@
       </p:sp>
       <p:sp>
         <p:nvSpPr>
-          <p:cNvPr id="7" name="TextBox 6"/>
+          <p:cNvPr id="15" name="TextBox 14"/>
           <p:cNvSpPr txBox="1"/>
           <p:nvPr/>
         </p:nvSpPr>
         <p:spPr>
           <a:xfrm>
-            <a:off x="4953304" y="521208"/>
-            <a:ext cx="2286000" cy="384048"/>
+            <a:off x="1600200" y="1645920"/>
+            <a:ext cx="1737360" cy="310896"/>
           </a:xfrm>
           <a:prstGeom prst="rect">
             <a:avLst/>
@@ -5350,21 +7194,21 @@
                 </a:solidFill>
                 <a:latin typeface="Microsoft YaHei"/>
               </a:rPr>
-              <a:t>比较阅读</a:t>
-            </a:r>
-          </a:p>
-        </p:txBody>
-      </p:sp>
-      <p:sp>
-        <p:nvSpPr>
-          <p:cNvPr id="8" name="TextBox 7"/>
+              <a:t>《风俗通》</a:t>
+            </a:r>
+          </a:p>
+        </p:txBody>
+      </p:sp>
+      <p:sp>
+        <p:nvSpPr>
+          <p:cNvPr id="16" name="TextBox 15"/>
           <p:cNvSpPr txBox="1"/>
           <p:nvPr/>
         </p:nvSpPr>
         <p:spPr>
           <a:xfrm>
-            <a:off x="1371600" y="960120"/>
-            <a:ext cx="9418320" cy="822960"/>
+            <a:off x="3474720" y="1627632"/>
+            <a:ext cx="7040879" cy="658368"/>
           </a:xfrm>
           <a:prstGeom prst="rect">
             <a:avLst/>
@@ -5372,40 +7216,83 @@
           <a:noFill/>
         </p:spPr>
         <p:txBody>
-          <a:bodyPr wrap="square">
+          <a:bodyPr wrap="none">
             <a:spAutoFit/>
           </a:bodyPr>
           <a:lstStyle/>
           <a:p>
-            <a:pPr algn="ctr">
+            <a:pPr algn="l">
               <a:spcAft>
                 <a:spcPts val="1000"/>
               </a:spcAft>
             </a:pPr>
             <a:r>
-              <a:rPr sz="3600" b="1">
+              <a:rPr sz="2100" b="0">
                 <a:solidFill>
-                  <a:srgbClr val="468250"/>
+                  <a:srgbClr val="28462D"/>
                 </a:solidFill>
                 <a:latin typeface="Microsoft YaHei"/>
               </a:rPr>
-              <a:t>学习任务二</a:t>
-            </a:r>
-          </a:p>
-        </p:txBody>
-      </p:sp>
-      <p:sp>
-        <p:nvSpPr>
-          <p:cNvPr id="9" name="Rectangle 8"/>
+              <a:t>记载简洁，重在说明造人方法</a:t>
+            </a:r>
+          </a:p>
+        </p:txBody>
+      </p:sp>
+      <p:sp>
+        <p:nvSpPr>
+          <p:cNvPr id="17" name="Rectangle 16"/>
           <p:cNvSpPr/>
           <p:nvPr/>
         </p:nvSpPr>
         <p:spPr>
           <a:xfrm>
-            <a:off x="3200400" y="1600200"/>
-            <a:ext cx="5760720" cy="27432"/>
-          </a:xfrm>
-          <a:prstGeom prst="rect">
+            <a:off x="1417320" y="3081527"/>
+            <a:ext cx="9601200" cy="13716"/>
+          </a:xfrm>
+          <a:prstGeom prst="rect">
+            <a:avLst/>
+          </a:prstGeom>
+          <a:solidFill>
+            <a:srgbClr val="D2C8AF"/>
+          </a:solidFill>
+          <a:ln>
+            <a:noFill/>
+          </a:ln>
+        </p:spPr>
+        <p:style>
+          <a:lnRef idx="1">
+            <a:schemeClr val="accent1"/>
+          </a:lnRef>
+          <a:fillRef idx="3">
+            <a:schemeClr val="accent1"/>
+          </a:fillRef>
+          <a:effectRef idx="2">
+            <a:schemeClr val="accent1"/>
+          </a:effectRef>
+          <a:fontRef idx="minor">
+            <a:schemeClr val="lt1"/>
+          </a:fontRef>
+        </p:style>
+        <p:txBody>
+          <a:bodyPr rtlCol="0" anchor="ctr"/>
+          <a:lstStyle/>
+          <a:p>
+            <a:pPr algn="ctr"/>
+          </a:p>
+        </p:txBody>
+      </p:sp>
+      <p:sp>
+        <p:nvSpPr>
+          <p:cNvPr id="18" name="Rounded Rectangle 17"/>
+          <p:cNvSpPr/>
+          <p:nvPr/>
+        </p:nvSpPr>
+        <p:spPr>
+          <a:xfrm>
+            <a:off x="1600200" y="2432303"/>
+            <a:ext cx="1280160" cy="347472"/>
+          </a:xfrm>
+          <a:prstGeom prst="roundRect">
             <a:avLst/>
           </a:prstGeom>
           <a:solidFill>
@@ -5439,25 +7326,101 @@
       </p:sp>
       <p:sp>
         <p:nvSpPr>
-          <p:cNvPr id="10" name="Rounded Rectangle 9"/>
+          <p:cNvPr id="19" name="TextBox 18"/>
+          <p:cNvSpPr txBox="1"/>
+          <p:nvPr/>
+        </p:nvSpPr>
+        <p:spPr>
+          <a:xfrm>
+            <a:off x="1600200" y="2450591"/>
+            <a:ext cx="1280160" cy="310896"/>
+          </a:xfrm>
+          <a:prstGeom prst="rect">
+            <a:avLst/>
+          </a:prstGeom>
+          <a:noFill/>
+        </p:spPr>
+        <p:txBody>
+          <a:bodyPr wrap="none">
+            <a:spAutoFit/>
+          </a:bodyPr>
+          <a:lstStyle/>
+          <a:p>
+            <a:pPr algn="ctr">
+              <a:spcAft>
+                <a:spcPts val="1000"/>
+              </a:spcAft>
+            </a:pPr>
+            <a:r>
+              <a:rPr sz="1800" b="1">
+                <a:solidFill>
+                  <a:srgbClr val="28462D"/>
+                </a:solidFill>
+                <a:latin typeface="Microsoft YaHei"/>
+              </a:rPr>
+              <a:t>课文</a:t>
+            </a:r>
+          </a:p>
+        </p:txBody>
+      </p:sp>
+      <p:sp>
+        <p:nvSpPr>
+          <p:cNvPr id="20" name="TextBox 19"/>
+          <p:cNvSpPr txBox="1"/>
+          <p:nvPr/>
+        </p:nvSpPr>
+        <p:spPr>
+          <a:xfrm>
+            <a:off x="3017520" y="2432303"/>
+            <a:ext cx="7498079" cy="658368"/>
+          </a:xfrm>
+          <a:prstGeom prst="rect">
+            <a:avLst/>
+          </a:prstGeom>
+          <a:noFill/>
+        </p:spPr>
+        <p:txBody>
+          <a:bodyPr wrap="none">
+            <a:spAutoFit/>
+          </a:bodyPr>
+          <a:lstStyle/>
+          <a:p>
+            <a:pPr algn="l">
+              <a:spcAft>
+                <a:spcPts val="1000"/>
+              </a:spcAft>
+            </a:pPr>
+            <a:r>
+              <a:rPr sz="2100" b="0">
+                <a:solidFill>
+                  <a:srgbClr val="28462D"/>
+                </a:solidFill>
+                <a:latin typeface="Microsoft YaHei"/>
+              </a:rPr>
+              <a:t>增加孤独心理、造人细节、情感描写</a:t>
+            </a:r>
+          </a:p>
+        </p:txBody>
+      </p:sp>
+      <p:sp>
+        <p:nvSpPr>
+          <p:cNvPr id="21" name="Rectangle 20"/>
           <p:cNvSpPr/>
           <p:nvPr/>
         </p:nvSpPr>
         <p:spPr>
           <a:xfrm>
-            <a:off x="1295704" y="1645920"/>
-            <a:ext cx="9601200" cy="2240280"/>
-          </a:xfrm>
-          <a:prstGeom prst="roundRect">
+            <a:off x="1417320" y="3886200"/>
+            <a:ext cx="9601200" cy="13716"/>
+          </a:xfrm>
+          <a:prstGeom prst="rect">
             <a:avLst/>
           </a:prstGeom>
           <a:solidFill>
-            <a:srgbClr val="F8FCF5"/>
+            <a:srgbClr val="D2C8AF"/>
           </a:solidFill>
-          <a:ln w="19050">
-            <a:solidFill>
-              <a:srgbClr val="A0C896"/>
-            </a:solidFill>
+          <a:ln>
+            <a:noFill/>
           </a:ln>
         </p:spPr>
         <p:style>
@@ -5484,20 +7447,20 @@
       </p:sp>
       <p:sp>
         <p:nvSpPr>
-          <p:cNvPr id="11" name="Oval 10"/>
+          <p:cNvPr id="22" name="Rounded Rectangle 21"/>
           <p:cNvSpPr/>
           <p:nvPr/>
         </p:nvSpPr>
         <p:spPr>
           <a:xfrm>
-            <a:off x="2255824" y="1828800"/>
-            <a:ext cx="384048" cy="384048"/>
-          </a:xfrm>
-          <a:prstGeom prst="ellipse">
+            <a:off x="1600200" y="3236976"/>
+            <a:ext cx="1444752" cy="347472"/>
+          </a:xfrm>
+          <a:prstGeom prst="roundRect">
             <a:avLst/>
           </a:prstGeom>
           <a:solidFill>
-            <a:srgbClr val="468250"/>
+            <a:srgbClr val="A0C896"/>
           </a:solidFill>
           <a:ln>
             <a:noFill/>
@@ -5527,14 +7490,14 @@
       </p:sp>
       <p:sp>
         <p:nvSpPr>
-          <p:cNvPr id="12" name="TextBox 11"/>
+          <p:cNvPr id="23" name="TextBox 22"/>
           <p:cNvSpPr txBox="1"/>
           <p:nvPr/>
         </p:nvSpPr>
         <p:spPr>
           <a:xfrm>
-            <a:off x="2255824" y="1847088"/>
-            <a:ext cx="384048" cy="365760"/>
+            <a:off x="1600200" y="3255264"/>
+            <a:ext cx="1444752" cy="310896"/>
           </a:xfrm>
           <a:prstGeom prst="rect">
             <a:avLst/>
@@ -5553,27 +7516,27 @@
               </a:spcAft>
             </a:pPr>
             <a:r>
-              <a:rPr sz="1600" b="1">
+              <a:rPr sz="1800" b="1">
                 <a:solidFill>
-                  <a:srgbClr val="FFFFFF"/>
+                  <a:srgbClr val="28462D"/>
                 </a:solidFill>
                 <a:latin typeface="Microsoft YaHei"/>
               </a:rPr>
-              <a:t>1</a:t>
-            </a:r>
-          </a:p>
-        </p:txBody>
-      </p:sp>
-      <p:sp>
-        <p:nvSpPr>
-          <p:cNvPr id="13" name="TextBox 12"/>
+              <a:t>改写意图</a:t>
+            </a:r>
+          </a:p>
+        </p:txBody>
+      </p:sp>
+      <p:sp>
+        <p:nvSpPr>
+          <p:cNvPr id="24" name="TextBox 23"/>
           <p:cNvSpPr txBox="1"/>
           <p:nvPr/>
         </p:nvSpPr>
         <p:spPr>
           <a:xfrm>
-            <a:off x="2758744" y="1810512"/>
-            <a:ext cx="7772400" cy="502920"/>
+            <a:off x="3182112" y="3236976"/>
+            <a:ext cx="7333488" cy="658368"/>
           </a:xfrm>
           <a:prstGeom prst="rect">
             <a:avLst/>
@@ -5592,33 +7555,33 @@
               </a:spcAft>
             </a:pPr>
             <a:r>
-              <a:rPr sz="2400" b="0">
+              <a:rPr sz="2100" b="0">
                 <a:solidFill>
                   <a:srgbClr val="28462D"/>
                 </a:solidFill>
                 <a:latin typeface="Microsoft YaHei"/>
               </a:rPr>
-              <a:t>阅读《风俗通》记载，完成「古籍与课文」比较表</a:t>
-            </a:r>
-          </a:p>
-        </p:txBody>
-      </p:sp>
-      <p:sp>
-        <p:nvSpPr>
-          <p:cNvPr id="14" name="Oval 13"/>
+              <a:t>让神话更生动，表达对生命与创造的礼赞</a:t>
+            </a:r>
+          </a:p>
+        </p:txBody>
+      </p:sp>
+      <p:sp>
+        <p:nvSpPr>
+          <p:cNvPr id="25" name="Rectangle 24"/>
           <p:cNvSpPr/>
           <p:nvPr/>
         </p:nvSpPr>
         <p:spPr>
           <a:xfrm>
-            <a:off x="2255824" y="2395728"/>
-            <a:ext cx="384048" cy="384048"/>
-          </a:xfrm>
-          <a:prstGeom prst="ellipse">
+            <a:off x="1417320" y="4690872"/>
+            <a:ext cx="9601200" cy="13716"/>
+          </a:xfrm>
+          <a:prstGeom prst="rect">
             <a:avLst/>
           </a:prstGeom>
           <a:solidFill>
-            <a:srgbClr val="468250"/>
+            <a:srgbClr val="D2C8AF"/>
           </a:solidFill>
           <a:ln>
             <a:noFill/>
@@ -5648,14 +7611,57 @@
       </p:sp>
       <p:sp>
         <p:nvSpPr>
-          <p:cNvPr id="15" name="TextBox 14"/>
+          <p:cNvPr id="26" name="Rounded Rectangle 25"/>
+          <p:cNvSpPr/>
+          <p:nvPr/>
+        </p:nvSpPr>
+        <p:spPr>
+          <a:xfrm>
+            <a:off x="1600200" y="4041648"/>
+            <a:ext cx="1444752" cy="347472"/>
+          </a:xfrm>
+          <a:prstGeom prst="roundRect">
+            <a:avLst/>
+          </a:prstGeom>
+          <a:solidFill>
+            <a:srgbClr val="A0C896"/>
+          </a:solidFill>
+          <a:ln>
+            <a:noFill/>
+          </a:ln>
+        </p:spPr>
+        <p:style>
+          <a:lnRef idx="1">
+            <a:schemeClr val="accent1"/>
+          </a:lnRef>
+          <a:fillRef idx="3">
+            <a:schemeClr val="accent1"/>
+          </a:fillRef>
+          <a:effectRef idx="2">
+            <a:schemeClr val="accent1"/>
+          </a:effectRef>
+          <a:fontRef idx="minor">
+            <a:schemeClr val="lt1"/>
+          </a:fontRef>
+        </p:style>
+        <p:txBody>
+          <a:bodyPr rtlCol="0" anchor="ctr"/>
+          <a:lstStyle/>
+          <a:p>
+            <a:pPr algn="ctr"/>
+          </a:p>
+        </p:txBody>
+      </p:sp>
+      <p:sp>
+        <p:nvSpPr>
+          <p:cNvPr id="27" name="TextBox 26"/>
           <p:cNvSpPr txBox="1"/>
           <p:nvPr/>
         </p:nvSpPr>
         <p:spPr>
           <a:xfrm>
-            <a:off x="2255824" y="2414016"/>
-            <a:ext cx="384048" cy="365760"/>
+            <a:off x="1600200" y="4059936"/>
+            <a:ext cx="1444752" cy="310896"/>
           </a:xfrm>
           <a:prstGeom prst="rect">
             <a:avLst/>
@@ -5674,27 +7680,27 @@
               </a:spcAft>
             </a:pPr>
             <a:r>
-              <a:rPr sz="1600" b="1">
+              <a:rPr sz="1800" b="1">
                 <a:solidFill>
-                  <a:srgbClr val="FFFFFF"/>
+                  <a:srgbClr val="28462D"/>
                 </a:solidFill>
                 <a:latin typeface="Microsoft YaHei"/>
               </a:rPr>
-              <a:t>2</a:t>
-            </a:r>
-          </a:p>
-        </p:txBody>
-      </p:sp>
-      <p:sp>
-        <p:nvSpPr>
-          <p:cNvPr id="16" name="TextBox 15"/>
+              <a:t>策展主题</a:t>
+            </a:r>
+          </a:p>
+        </p:txBody>
+      </p:sp>
+      <p:sp>
+        <p:nvSpPr>
+          <p:cNvPr id="28" name="TextBox 27"/>
           <p:cNvSpPr txBox="1"/>
           <p:nvPr/>
         </p:nvSpPr>
         <p:spPr>
           <a:xfrm>
-            <a:off x="2758744" y="2377440"/>
-            <a:ext cx="7772400" cy="502920"/>
+            <a:off x="3182112" y="4041648"/>
+            <a:ext cx="7333488" cy="658368"/>
           </a:xfrm>
           <a:prstGeom prst="rect">
             <a:avLst/>
@@ -5713,134 +7719,13 @@
               </a:spcAft>
             </a:pPr>
             <a:r>
-              <a:rPr sz="2400" b="0">
+              <a:rPr sz="2100" b="0">
                 <a:solidFill>
                   <a:srgbClr val="28462D"/>
                 </a:solidFill>
                 <a:latin typeface="Microsoft YaHei"/>
               </a:rPr>
-              <a:t>细读池水照影、黄泥捏人、藤条挥洒等画面</a:t>
-            </a:r>
-          </a:p>
-        </p:txBody>
-      </p:sp>
-      <p:sp>
-        <p:nvSpPr>
-          <p:cNvPr id="17" name="Oval 16"/>
-          <p:cNvSpPr/>
-          <p:nvPr/>
-        </p:nvSpPr>
-        <p:spPr>
-          <a:xfrm>
-            <a:off x="2255824" y="2962656"/>
-            <a:ext cx="384048" cy="384048"/>
-          </a:xfrm>
-          <a:prstGeom prst="ellipse">
-            <a:avLst/>
-          </a:prstGeom>
-          <a:solidFill>
-            <a:srgbClr val="468250"/>
-          </a:solidFill>
-          <a:ln>
-            <a:noFill/>
-          </a:ln>
-        </p:spPr>
-        <p:style>
-          <a:lnRef idx="1">
-            <a:schemeClr val="accent1"/>
-          </a:lnRef>
-          <a:fillRef idx="3">
-            <a:schemeClr val="accent1"/>
-          </a:fillRef>
-          <a:effectRef idx="2">
-            <a:schemeClr val="accent1"/>
-          </a:effectRef>
-          <a:fontRef idx="minor">
-            <a:schemeClr val="lt1"/>
-          </a:fontRef>
-        </p:style>
-        <p:txBody>
-          <a:bodyPr rtlCol="0" anchor="ctr"/>
-          <a:lstStyle/>
-          <a:p>
-            <a:pPr algn="ctr"/>
-          </a:p>
-        </p:txBody>
-      </p:sp>
-      <p:sp>
-        <p:nvSpPr>
-          <p:cNvPr id="18" name="TextBox 17"/>
-          <p:cNvSpPr txBox="1"/>
-          <p:nvPr/>
-        </p:nvSpPr>
-        <p:spPr>
-          <a:xfrm>
-            <a:off x="2255824" y="2980944"/>
-            <a:ext cx="384048" cy="365760"/>
-          </a:xfrm>
-          <a:prstGeom prst="rect">
-            <a:avLst/>
-          </a:prstGeom>
-          <a:noFill/>
-        </p:spPr>
-        <p:txBody>
-          <a:bodyPr wrap="none">
-            <a:spAutoFit/>
-          </a:bodyPr>
-          <a:lstStyle/>
-          <a:p>
-            <a:pPr algn="ctr">
-              <a:spcAft>
-                <a:spcPts val="1000"/>
-              </a:spcAft>
-            </a:pPr>
-            <a:r>
-              <a:rPr sz="1600" b="1">
-                <a:solidFill>
-                  <a:srgbClr val="FFFFFF"/>
-                </a:solidFill>
-                <a:latin typeface="Microsoft YaHei"/>
-              </a:rPr>
-              <a:t>3</a:t>
-            </a:r>
-          </a:p>
-        </p:txBody>
-      </p:sp>
-      <p:sp>
-        <p:nvSpPr>
-          <p:cNvPr id="19" name="TextBox 18"/>
-          <p:cNvSpPr txBox="1"/>
-          <p:nvPr/>
-        </p:nvSpPr>
-        <p:spPr>
-          <a:xfrm>
-            <a:off x="2758744" y="2944368"/>
-            <a:ext cx="7772400" cy="502920"/>
-          </a:xfrm>
-          <a:prstGeom prst="rect">
-            <a:avLst/>
-          </a:prstGeom>
-          <a:noFill/>
-        </p:spPr>
-        <p:txBody>
-          <a:bodyPr wrap="none">
-            <a:spAutoFit/>
-          </a:bodyPr>
-          <a:lstStyle/>
-          <a:p>
-            <a:pPr algn="l">
-              <a:spcAft>
-                <a:spcPts val="1000"/>
-              </a:spcAft>
-            </a:pPr>
-            <a:r>
-              <a:rPr sz="2400" b="0">
-                <a:solidFill>
-                  <a:srgbClr val="28462D"/>
-                </a:solidFill>
-                <a:latin typeface="Microsoft YaHei"/>
-              </a:rPr>
-              <a:t>说说想象如何具体、生动、温暖</a:t>
+              <a:t>生命来之不易，创造值得珍视（创造与生命）</a:t>
             </a:r>
           </a:p>
         </p:txBody>
@@ -5986,6 +7871,88 @@
         </p:nvSpPr>
         <p:spPr>
           <a:xfrm>
+            <a:off x="502920" y="384048"/>
+            <a:ext cx="2011680" cy="384048"/>
+          </a:xfrm>
+          <a:prstGeom prst="roundRect">
+            <a:avLst/>
+          </a:prstGeom>
+          <a:solidFill>
+            <a:srgbClr val="3C9664"/>
+          </a:solidFill>
+          <a:ln>
+            <a:noFill/>
+          </a:ln>
+        </p:spPr>
+        <p:style>
+          <a:lnRef idx="1">
+            <a:schemeClr val="accent1"/>
+          </a:lnRef>
+          <a:fillRef idx="3">
+            <a:schemeClr val="accent1"/>
+          </a:fillRef>
+          <a:effectRef idx="2">
+            <a:schemeClr val="accent1"/>
+          </a:effectRef>
+          <a:fontRef idx="minor">
+            <a:schemeClr val="lt1"/>
+          </a:fontRef>
+        </p:style>
+        <p:txBody>
+          <a:bodyPr rtlCol="0" anchor="ctr"/>
+          <a:lstStyle/>
+          <a:p>
+            <a:pPr algn="ctr"/>
+          </a:p>
+        </p:txBody>
+      </p:sp>
+      <p:sp>
+        <p:nvSpPr>
+          <p:cNvPr id="7" name="TextBox 6"/>
+          <p:cNvSpPr txBox="1"/>
+          <p:nvPr/>
+        </p:nvSpPr>
+        <p:spPr>
+          <a:xfrm>
+            <a:off x="502920" y="402336"/>
+            <a:ext cx="2011680" cy="347472"/>
+          </a:xfrm>
+          <a:prstGeom prst="rect">
+            <a:avLst/>
+          </a:prstGeom>
+          <a:noFill/>
+        </p:spPr>
+        <p:txBody>
+          <a:bodyPr wrap="none">
+            <a:spAutoFit/>
+          </a:bodyPr>
+          <a:lstStyle/>
+          <a:p>
+            <a:pPr algn="ctr">
+              <a:spcAft>
+                <a:spcPts val="1000"/>
+              </a:spcAft>
+            </a:pPr>
+            <a:r>
+              <a:rPr sz="1600" b="1">
+                <a:solidFill>
+                  <a:srgbClr val="FFFFFF"/>
+                </a:solidFill>
+                <a:latin typeface="Microsoft YaHei"/>
+              </a:rPr>
+              <a:t>课堂活动</a:t>
+            </a:r>
+          </a:p>
+        </p:txBody>
+      </p:sp>
+      <p:sp>
+        <p:nvSpPr>
+          <p:cNvPr id="8" name="Rounded Rectangle 7"/>
+          <p:cNvSpPr/>
+          <p:nvPr/>
+        </p:nvSpPr>
+        <p:spPr>
+          <a:xfrm>
             <a:off x="4953304" y="502920"/>
             <a:ext cx="2286000" cy="411480"/>
           </a:xfrm>
@@ -6023,7 +7990,7 @@
       </p:sp>
       <p:sp>
         <p:nvSpPr>
-          <p:cNvPr id="7" name="TextBox 6"/>
+          <p:cNvPr id="9" name="TextBox 8"/>
           <p:cNvSpPr txBox="1"/>
           <p:nvPr/>
         </p:nvSpPr>
@@ -6055,14 +8022,14 @@
                 </a:solidFill>
                 <a:latin typeface="Microsoft YaHei"/>
               </a:rPr>
-              <a:t>主题探究</a:t>
-            </a:r>
-          </a:p>
-        </p:txBody>
-      </p:sp>
-      <p:sp>
-        <p:nvSpPr>
-          <p:cNvPr id="8" name="TextBox 7"/>
+              <a:t>课堂活动</a:t>
+            </a:r>
+          </a:p>
+        </p:txBody>
+      </p:sp>
+      <p:sp>
+        <p:nvSpPr>
+          <p:cNvPr id="10" name="TextBox 9"/>
           <p:cNvSpPr txBox="1"/>
           <p:nvPr/>
         </p:nvSpPr>
@@ -6094,14 +8061,14 @@
                 </a:solidFill>
                 <a:latin typeface="Microsoft YaHei"/>
               </a:rPr>
-              <a:t>学习任务三</a:t>
-            </a:r>
-          </a:p>
-        </p:txBody>
-      </p:sp>
-      <p:sp>
-        <p:nvSpPr>
-          <p:cNvPr id="9" name="Rectangle 8"/>
+              <a:t>学习任务</a:t>
+            </a:r>
+          </a:p>
+        </p:txBody>
+      </p:sp>
+      <p:sp>
+        <p:nvSpPr>
+          <p:cNvPr id="11" name="Rectangle 10"/>
           <p:cNvSpPr/>
           <p:nvPr/>
         </p:nvSpPr>
@@ -6144,14 +8111,14 @@
       </p:sp>
       <p:sp>
         <p:nvSpPr>
-          <p:cNvPr id="10" name="Rounded Rectangle 9"/>
+          <p:cNvPr id="12" name="Rounded Rectangle 11"/>
           <p:cNvSpPr/>
           <p:nvPr/>
         </p:nvSpPr>
         <p:spPr>
           <a:xfrm>
             <a:off x="1295704" y="1645920"/>
-            <a:ext cx="9601200" cy="2240280"/>
+            <a:ext cx="9601200" cy="2112264"/>
           </a:xfrm>
           <a:prstGeom prst="roundRect">
             <a:avLst/>
@@ -6189,14 +8156,14 @@
       </p:sp>
       <p:sp>
         <p:nvSpPr>
-          <p:cNvPr id="11" name="Oval 10"/>
+          <p:cNvPr id="13" name="Oval 12"/>
           <p:cNvSpPr/>
           <p:nvPr/>
         </p:nvSpPr>
         <p:spPr>
           <a:xfrm>
             <a:off x="2255824" y="1828800"/>
-            <a:ext cx="384048" cy="384048"/>
+            <a:ext cx="347472" cy="347472"/>
           </a:xfrm>
           <a:prstGeom prst="ellipse">
             <a:avLst/>
@@ -6232,14 +8199,14 @@
       </p:sp>
       <p:sp>
         <p:nvSpPr>
-          <p:cNvPr id="12" name="TextBox 11"/>
+          <p:cNvPr id="14" name="TextBox 13"/>
           <p:cNvSpPr txBox="1"/>
           <p:nvPr/>
         </p:nvSpPr>
         <p:spPr>
           <a:xfrm>
             <a:off x="2255824" y="1847088"/>
-            <a:ext cx="384048" cy="365760"/>
+            <a:ext cx="347472" cy="329184"/>
           </a:xfrm>
           <a:prstGeom prst="rect">
             <a:avLst/>
@@ -6258,7 +8225,7 @@
               </a:spcAft>
             </a:pPr>
             <a:r>
-              <a:rPr sz="1600" b="1">
+              <a:rPr sz="1400" b="1">
                 <a:solidFill>
                   <a:srgbClr val="FFFFFF"/>
                 </a:solidFill>
@@ -6271,14 +8238,14 @@
       </p:sp>
       <p:sp>
         <p:nvSpPr>
-          <p:cNvPr id="13" name="TextBox 12"/>
+          <p:cNvPr id="15" name="TextBox 14"/>
           <p:cNvSpPr txBox="1"/>
           <p:nvPr/>
         </p:nvSpPr>
         <p:spPr>
           <a:xfrm>
-            <a:off x="2758744" y="1810512"/>
-            <a:ext cx="7772400" cy="502920"/>
+            <a:off x="2713024" y="1810512"/>
+            <a:ext cx="7863840" cy="457200"/>
           </a:xfrm>
           <a:prstGeom prst="rect">
             <a:avLst/>
@@ -6303,21 +8270,21 @@
                 </a:solidFill>
                 <a:latin typeface="Microsoft YaHei"/>
               </a:rPr>
-              <a:t>讨论：神话用想象解释人的来处</a:t>
-            </a:r>
-          </a:p>
-        </p:txBody>
-      </p:sp>
-      <p:sp>
-        <p:nvSpPr>
-          <p:cNvPr id="14" name="Oval 13"/>
+              <a:t>给女娲行动排序，比较两种造人方法</a:t>
+            </a:r>
+          </a:p>
+        </p:txBody>
+      </p:sp>
+      <p:sp>
+        <p:nvSpPr>
+          <p:cNvPr id="16" name="Oval 15"/>
           <p:cNvSpPr/>
           <p:nvPr/>
         </p:nvSpPr>
         <p:spPr>
           <a:xfrm>
             <a:off x="2255824" y="2395728"/>
-            <a:ext cx="384048" cy="384048"/>
+            <a:ext cx="347472" cy="347472"/>
           </a:xfrm>
           <a:prstGeom prst="ellipse">
             <a:avLst/>
@@ -6353,14 +8320,14 @@
       </p:sp>
       <p:sp>
         <p:nvSpPr>
-          <p:cNvPr id="15" name="TextBox 14"/>
+          <p:cNvPr id="17" name="TextBox 16"/>
           <p:cNvSpPr txBox="1"/>
           <p:nvPr/>
         </p:nvSpPr>
         <p:spPr>
           <a:xfrm>
             <a:off x="2255824" y="2414016"/>
-            <a:ext cx="384048" cy="365760"/>
+            <a:ext cx="347472" cy="329184"/>
           </a:xfrm>
           <a:prstGeom prst="rect">
             <a:avLst/>
@@ -6379,7 +8346,7 @@
               </a:spcAft>
             </a:pPr>
             <a:r>
-              <a:rPr sz="1600" b="1">
+              <a:rPr sz="1400" b="1">
                 <a:solidFill>
                   <a:srgbClr val="FFFFFF"/>
                 </a:solidFill>
@@ -6392,14 +8359,14 @@
       </p:sp>
       <p:sp>
         <p:nvSpPr>
-          <p:cNvPr id="16" name="TextBox 15"/>
+          <p:cNvPr id="18" name="TextBox 17"/>
           <p:cNvSpPr txBox="1"/>
           <p:nvPr/>
         </p:nvSpPr>
         <p:spPr>
           <a:xfrm>
-            <a:off x="2758744" y="2377440"/>
-            <a:ext cx="7772400" cy="502920"/>
+            <a:off x="2713024" y="2377440"/>
+            <a:ext cx="7863840" cy="457200"/>
           </a:xfrm>
           <a:prstGeom prst="rect">
             <a:avLst/>
@@ -6424,21 +8391,21 @@
                 </a:solidFill>
                 <a:latin typeface="Microsoft YaHei"/>
               </a:rPr>
-              <a:t>女娲既有神性，也有人的孤独、疲倦和喜悦</a:t>
-            </a:r>
-          </a:p>
-        </p:txBody>
-      </p:sp>
-      <p:sp>
-        <p:nvSpPr>
-          <p:cNvPr id="17" name="Oval 16"/>
+              <a:t>完成「古籍与课文」比较表</a:t>
+            </a:r>
+          </a:p>
+        </p:txBody>
+      </p:sp>
+      <p:sp>
+        <p:nvSpPr>
+          <p:cNvPr id="19" name="Oval 18"/>
           <p:cNvSpPr/>
           <p:nvPr/>
         </p:nvSpPr>
         <p:spPr>
           <a:xfrm>
             <a:off x="2255824" y="2962656"/>
-            <a:ext cx="384048" cy="384048"/>
+            <a:ext cx="347472" cy="347472"/>
           </a:xfrm>
           <a:prstGeom prst="ellipse">
             <a:avLst/>
@@ -6474,14 +8441,14 @@
       </p:sp>
       <p:sp>
         <p:nvSpPr>
-          <p:cNvPr id="18" name="TextBox 17"/>
+          <p:cNvPr id="20" name="TextBox 19"/>
           <p:cNvSpPr txBox="1"/>
           <p:nvPr/>
         </p:nvSpPr>
         <p:spPr>
           <a:xfrm>
             <a:off x="2255824" y="2980944"/>
-            <a:ext cx="384048" cy="365760"/>
+            <a:ext cx="347472" cy="329184"/>
           </a:xfrm>
           <a:prstGeom prst="rect">
             <a:avLst/>
@@ -6500,7 +8467,7 @@
               </a:spcAft>
             </a:pPr>
             <a:r>
-              <a:rPr sz="1600" b="1">
+              <a:rPr sz="1400" b="1">
                 <a:solidFill>
                   <a:srgbClr val="FFFFFF"/>
                 </a:solidFill>
@@ -6513,14 +8480,14 @@
       </p:sp>
       <p:sp>
         <p:nvSpPr>
-          <p:cNvPr id="19" name="TextBox 18"/>
+          <p:cNvPr id="21" name="TextBox 20"/>
           <p:cNvSpPr txBox="1"/>
           <p:nvPr/>
         </p:nvSpPr>
         <p:spPr>
           <a:xfrm>
-            <a:off x="2758744" y="2944368"/>
-            <a:ext cx="7772400" cy="502920"/>
+            <a:off x="2713024" y="2944368"/>
+            <a:ext cx="7863840" cy="457200"/>
           </a:xfrm>
           <a:prstGeom prst="rect">
             <a:avLst/>
@@ -6545,7 +8512,7 @@
                 </a:solidFill>
                 <a:latin typeface="Microsoft YaHei"/>
               </a:rPr>
-              <a:t>策展主题三：生命来之不易，创造值得礼赞</a:t>
+              <a:t>以「我看见女娲……」写100字画面描述</a:t>
             </a:r>
           </a:p>
         </p:txBody>
@@ -6691,6 +8658,88 @@
         </p:nvSpPr>
         <p:spPr>
           <a:xfrm>
+            <a:off x="502920" y="384048"/>
+            <a:ext cx="2011680" cy="384048"/>
+          </a:xfrm>
+          <a:prstGeom prst="roundRect">
+            <a:avLst/>
+          </a:prstGeom>
+          <a:solidFill>
+            <a:srgbClr val="3C9664"/>
+          </a:solidFill>
+          <a:ln>
+            <a:noFill/>
+          </a:ln>
+        </p:spPr>
+        <p:style>
+          <a:lnRef idx="1">
+            <a:schemeClr val="accent1"/>
+          </a:lnRef>
+          <a:fillRef idx="3">
+            <a:schemeClr val="accent1"/>
+          </a:fillRef>
+          <a:effectRef idx="2">
+            <a:schemeClr val="accent1"/>
+          </a:effectRef>
+          <a:fontRef idx="minor">
+            <a:schemeClr val="lt1"/>
+          </a:fontRef>
+        </p:style>
+        <p:txBody>
+          <a:bodyPr rtlCol="0" anchor="ctr"/>
+          <a:lstStyle/>
+          <a:p>
+            <a:pPr algn="ctr"/>
+          </a:p>
+        </p:txBody>
+      </p:sp>
+      <p:sp>
+        <p:nvSpPr>
+          <p:cNvPr id="7" name="TextBox 6"/>
+          <p:cNvSpPr txBox="1"/>
+          <p:nvPr/>
+        </p:nvSpPr>
+        <p:spPr>
+          <a:xfrm>
+            <a:off x="502920" y="402336"/>
+            <a:ext cx="2011680" cy="347472"/>
+          </a:xfrm>
+          <a:prstGeom prst="rect">
+            <a:avLst/>
+          </a:prstGeom>
+          <a:noFill/>
+        </p:spPr>
+        <p:txBody>
+          <a:bodyPr wrap="none">
+            <a:spAutoFit/>
+          </a:bodyPr>
+          <a:lstStyle/>
+          <a:p>
+            <a:pPr algn="ctr">
+              <a:spcAft>
+                <a:spcPts val="1000"/>
+              </a:spcAft>
+            </a:pPr>
+            <a:r>
+              <a:rPr sz="1600" b="1">
+                <a:solidFill>
+                  <a:srgbClr val="FFFFFF"/>
+                </a:solidFill>
+                <a:latin typeface="Microsoft YaHei"/>
+              </a:rPr>
+              <a:t>课堂活动</a:t>
+            </a:r>
+          </a:p>
+        </p:txBody>
+      </p:sp>
+      <p:sp>
+        <p:nvSpPr>
+          <p:cNvPr id="8" name="Rounded Rectangle 7"/>
+          <p:cNvSpPr/>
+          <p:nvPr/>
+        </p:nvSpPr>
+        <p:spPr>
+          <a:xfrm>
             <a:off x="4953304" y="502920"/>
             <a:ext cx="2286000" cy="411480"/>
           </a:xfrm>
@@ -6728,7 +8777,7 @@
       </p:sp>
       <p:sp>
         <p:nvSpPr>
-          <p:cNvPr id="7" name="TextBox 6"/>
+          <p:cNvPr id="9" name="TextBox 8"/>
           <p:cNvSpPr txBox="1"/>
           <p:nvPr/>
         </p:nvSpPr>
@@ -6767,7 +8816,7 @@
       </p:sp>
       <p:sp>
         <p:nvSpPr>
-          <p:cNvPr id="8" name="TextBox 7"/>
+          <p:cNvPr id="10" name="TextBox 9"/>
           <p:cNvSpPr txBox="1"/>
           <p:nvPr/>
         </p:nvSpPr>
@@ -6806,7 +8855,7 @@
       </p:sp>
       <p:sp>
         <p:nvSpPr>
-          <p:cNvPr id="9" name="Rectangle 8"/>
+          <p:cNvPr id="11" name="Rectangle 10"/>
           <p:cNvSpPr/>
           <p:nvPr/>
         </p:nvSpPr>
@@ -6849,14 +8898,14 @@
       </p:sp>
       <p:sp>
         <p:nvSpPr>
-          <p:cNvPr id="10" name="Rounded Rectangle 9"/>
+          <p:cNvPr id="12" name="Rounded Rectangle 11"/>
           <p:cNvSpPr/>
           <p:nvPr/>
         </p:nvSpPr>
         <p:spPr>
           <a:xfrm>
             <a:off x="1295704" y="1645920"/>
-            <a:ext cx="9601200" cy="2240280"/>
+            <a:ext cx="9601200" cy="1837944"/>
           </a:xfrm>
           <a:prstGeom prst="roundRect">
             <a:avLst/>
@@ -6894,14 +8943,14 @@
       </p:sp>
       <p:sp>
         <p:nvSpPr>
-          <p:cNvPr id="11" name="Oval 10"/>
+          <p:cNvPr id="13" name="Oval 12"/>
           <p:cNvSpPr/>
           <p:nvPr/>
         </p:nvSpPr>
         <p:spPr>
           <a:xfrm>
             <a:off x="2255824" y="1828800"/>
-            <a:ext cx="384048" cy="384048"/>
+            <a:ext cx="347472" cy="347472"/>
           </a:xfrm>
           <a:prstGeom prst="ellipse">
             <a:avLst/>
@@ -6937,14 +8986,14 @@
       </p:sp>
       <p:sp>
         <p:nvSpPr>
-          <p:cNvPr id="12" name="TextBox 11"/>
+          <p:cNvPr id="14" name="TextBox 13"/>
           <p:cNvSpPr txBox="1"/>
           <p:nvPr/>
         </p:nvSpPr>
         <p:spPr>
           <a:xfrm>
             <a:off x="2255824" y="1847088"/>
-            <a:ext cx="384048" cy="365760"/>
+            <a:ext cx="347472" cy="329184"/>
           </a:xfrm>
           <a:prstGeom prst="rect">
             <a:avLst/>
@@ -6963,7 +9012,7 @@
               </a:spcAft>
             </a:pPr>
             <a:r>
-              <a:rPr sz="1600" b="1">
+              <a:rPr sz="1400" b="1">
                 <a:solidFill>
                   <a:srgbClr val="FFFFFF"/>
                 </a:solidFill>
@@ -6976,14 +9025,14 @@
       </p:sp>
       <p:sp>
         <p:nvSpPr>
-          <p:cNvPr id="13" name="TextBox 12"/>
+          <p:cNvPr id="15" name="TextBox 14"/>
           <p:cNvSpPr txBox="1"/>
           <p:nvPr/>
         </p:nvSpPr>
         <p:spPr>
           <a:xfrm>
-            <a:off x="2758744" y="1810512"/>
-            <a:ext cx="7772400" cy="502920"/>
+            <a:off x="2713024" y="1810512"/>
+            <a:ext cx="7863840" cy="457200"/>
           </a:xfrm>
           <a:prstGeom prst="rect">
             <a:avLst/>
@@ -7002,27 +9051,27 @@
               </a:spcAft>
             </a:pPr>
             <a:r>
-              <a:rPr sz="2400" b="0">
+              <a:rPr sz="2200" b="0">
                 <a:solidFill>
                   <a:srgbClr val="28462D"/>
                 </a:solidFill>
                 <a:latin typeface="Microsoft YaHei"/>
               </a:rPr>
-              <a:t>神话改写基于古籍又超越古籍</a:t>
-            </a:r>
-          </a:p>
-        </p:txBody>
-      </p:sp>
-      <p:sp>
-        <p:nvSpPr>
-          <p:cNvPr id="14" name="Oval 13"/>
+              <a:t>神话想象：基于古籍，超越古籍，有温度</a:t>
+            </a:r>
+          </a:p>
+        </p:txBody>
+      </p:sp>
+      <p:sp>
+        <p:nvSpPr>
+          <p:cNvPr id="16" name="Oval 15"/>
           <p:cNvSpPr/>
           <p:nvPr/>
         </p:nvSpPr>
         <p:spPr>
           <a:xfrm>
-            <a:off x="2255824" y="2395728"/>
-            <a:ext cx="384048" cy="384048"/>
+            <a:off x="2255824" y="2304288"/>
+            <a:ext cx="347472" cy="347472"/>
           </a:xfrm>
           <a:prstGeom prst="ellipse">
             <a:avLst/>
@@ -7058,14 +9107,14 @@
       </p:sp>
       <p:sp>
         <p:nvSpPr>
-          <p:cNvPr id="15" name="TextBox 14"/>
+          <p:cNvPr id="17" name="TextBox 16"/>
           <p:cNvSpPr txBox="1"/>
           <p:nvPr/>
         </p:nvSpPr>
         <p:spPr>
           <a:xfrm>
-            <a:off x="2255824" y="2414016"/>
-            <a:ext cx="384048" cy="365760"/>
+            <a:off x="2255824" y="2322576"/>
+            <a:ext cx="347472" cy="329184"/>
           </a:xfrm>
           <a:prstGeom prst="rect">
             <a:avLst/>
@@ -7084,7 +9133,7 @@
               </a:spcAft>
             </a:pPr>
             <a:r>
-              <a:rPr sz="1600" b="1">
+              <a:rPr sz="1400" b="1">
                 <a:solidFill>
                   <a:srgbClr val="FFFFFF"/>
                 </a:solidFill>
@@ -7097,14 +9146,14 @@
       </p:sp>
       <p:sp>
         <p:nvSpPr>
-          <p:cNvPr id="16" name="TextBox 15"/>
+          <p:cNvPr id="18" name="TextBox 17"/>
           <p:cNvSpPr txBox="1"/>
           <p:nvPr/>
         </p:nvSpPr>
         <p:spPr>
           <a:xfrm>
-            <a:off x="2758744" y="2377440"/>
-            <a:ext cx="7772400" cy="502920"/>
+            <a:off x="2713024" y="2286000"/>
+            <a:ext cx="7863840" cy="457200"/>
           </a:xfrm>
           <a:prstGeom prst="rect">
             <a:avLst/>
@@ -7123,27 +9172,27 @@
               </a:spcAft>
             </a:pPr>
             <a:r>
-              <a:rPr sz="2400" b="0">
+              <a:rPr sz="2200" b="0">
                 <a:solidFill>
                   <a:srgbClr val="28462D"/>
                 </a:solidFill>
                 <a:latin typeface="Microsoft YaHei"/>
               </a:rPr>
-              <a:t>赋予创世故事现代意识与生命温度</a:t>
-            </a:r>
-          </a:p>
-        </p:txBody>
-      </p:sp>
-      <p:sp>
-        <p:nvSpPr>
-          <p:cNvPr id="17" name="Oval 16"/>
+              <a:t>女娲：神性与人性并存——孤独、疲倦、喜悦</a:t>
+            </a:r>
+          </a:p>
+        </p:txBody>
+      </p:sp>
+      <p:sp>
+        <p:nvSpPr>
+          <p:cNvPr id="19" name="Oval 18"/>
           <p:cNvSpPr/>
           <p:nvPr/>
         </p:nvSpPr>
         <p:spPr>
           <a:xfrm>
-            <a:off x="2255824" y="2962656"/>
-            <a:ext cx="384048" cy="384048"/>
+            <a:off x="2255824" y="2779776"/>
+            <a:ext cx="347472" cy="347472"/>
           </a:xfrm>
           <a:prstGeom prst="ellipse">
             <a:avLst/>
@@ -7179,14 +9228,14 @@
       </p:sp>
       <p:sp>
         <p:nvSpPr>
-          <p:cNvPr id="18" name="TextBox 17"/>
+          <p:cNvPr id="20" name="TextBox 19"/>
           <p:cNvSpPr txBox="1"/>
           <p:nvPr/>
         </p:nvSpPr>
         <p:spPr>
           <a:xfrm>
-            <a:off x="2255824" y="2980944"/>
-            <a:ext cx="384048" cy="365760"/>
+            <a:off x="2255824" y="2798064"/>
+            <a:ext cx="347472" cy="329184"/>
           </a:xfrm>
           <a:prstGeom prst="rect">
             <a:avLst/>
@@ -7205,7 +9254,7 @@
               </a:spcAft>
             </a:pPr>
             <a:r>
-              <a:rPr sz="1600" b="1">
+              <a:rPr sz="1400" b="1">
                 <a:solidFill>
                   <a:srgbClr val="FFFFFF"/>
                 </a:solidFill>
@@ -7218,14 +9267,14 @@
       </p:sp>
       <p:sp>
         <p:nvSpPr>
-          <p:cNvPr id="19" name="TextBox 18"/>
+          <p:cNvPr id="21" name="TextBox 20"/>
           <p:cNvSpPr txBox="1"/>
           <p:nvPr/>
         </p:nvSpPr>
         <p:spPr>
           <a:xfrm>
-            <a:off x="2758744" y="2944368"/>
-            <a:ext cx="7772400" cy="502920"/>
+            <a:off x="2713024" y="2761488"/>
+            <a:ext cx="7863840" cy="457200"/>
           </a:xfrm>
           <a:prstGeom prst="rect">
             <a:avLst/>
@@ -7244,13 +9293,13 @@
               </a:spcAft>
             </a:pPr>
             <a:r>
-              <a:rPr sz="2400" b="0">
+              <a:rPr sz="2200" b="0">
                 <a:solidFill>
                   <a:srgbClr val="28462D"/>
                 </a:solidFill>
                 <a:latin typeface="Microsoft YaHei"/>
               </a:rPr>
-              <a:t>策展主题：创造与生命</a:t>
+              <a:t>策展主题三：创造与生命</a:t>
             </a:r>
           </a:p>
         </p:txBody>
@@ -7396,6 +9445,88 @@
         </p:nvSpPr>
         <p:spPr>
           <a:xfrm>
+            <a:off x="502920" y="384048"/>
+            <a:ext cx="2011680" cy="384048"/>
+          </a:xfrm>
+          <a:prstGeom prst="roundRect">
+            <a:avLst/>
+          </a:prstGeom>
+          <a:solidFill>
+            <a:srgbClr val="3C9664"/>
+          </a:solidFill>
+          <a:ln>
+            <a:noFill/>
+          </a:ln>
+        </p:spPr>
+        <p:style>
+          <a:lnRef idx="1">
+            <a:schemeClr val="accent1"/>
+          </a:lnRef>
+          <a:fillRef idx="3">
+            <a:schemeClr val="accent1"/>
+          </a:fillRef>
+          <a:effectRef idx="2">
+            <a:schemeClr val="accent1"/>
+          </a:effectRef>
+          <a:fontRef idx="minor">
+            <a:schemeClr val="lt1"/>
+          </a:fontRef>
+        </p:style>
+        <p:txBody>
+          <a:bodyPr rtlCol="0" anchor="ctr"/>
+          <a:lstStyle/>
+          <a:p>
+            <a:pPr algn="ctr"/>
+          </a:p>
+        </p:txBody>
+      </p:sp>
+      <p:sp>
+        <p:nvSpPr>
+          <p:cNvPr id="7" name="TextBox 6"/>
+          <p:cNvSpPr txBox="1"/>
+          <p:nvPr/>
+        </p:nvSpPr>
+        <p:spPr>
+          <a:xfrm>
+            <a:off x="502920" y="402336"/>
+            <a:ext cx="2011680" cy="347472"/>
+          </a:xfrm>
+          <a:prstGeom prst="rect">
+            <a:avLst/>
+          </a:prstGeom>
+          <a:noFill/>
+        </p:spPr>
+        <p:txBody>
+          <a:bodyPr wrap="none">
+            <a:spAutoFit/>
+          </a:bodyPr>
+          <a:lstStyle/>
+          <a:p>
+            <a:pPr algn="ctr">
+              <a:spcAft>
+                <a:spcPts val="1000"/>
+              </a:spcAft>
+            </a:pPr>
+            <a:r>
+              <a:rPr sz="1600" b="1">
+                <a:solidFill>
+                  <a:srgbClr val="FFFFFF"/>
+                </a:solidFill>
+                <a:latin typeface="Microsoft YaHei"/>
+              </a:rPr>
+              <a:t>课堂活动</a:t>
+            </a:r>
+          </a:p>
+        </p:txBody>
+      </p:sp>
+      <p:sp>
+        <p:nvSpPr>
+          <p:cNvPr id="8" name="Rounded Rectangle 7"/>
+          <p:cNvSpPr/>
+          <p:nvPr/>
+        </p:nvSpPr>
+        <p:spPr>
+          <a:xfrm>
             <a:off x="4953304" y="502920"/>
             <a:ext cx="2286000" cy="411480"/>
           </a:xfrm>
@@ -7433,7 +9564,7 @@
       </p:sp>
       <p:sp>
         <p:nvSpPr>
-          <p:cNvPr id="7" name="TextBox 6"/>
+          <p:cNvPr id="9" name="TextBox 8"/>
           <p:cNvSpPr txBox="1"/>
           <p:nvPr/>
         </p:nvSpPr>
@@ -7472,7 +9603,7 @@
       </p:sp>
       <p:sp>
         <p:nvSpPr>
-          <p:cNvPr id="8" name="TextBox 7"/>
+          <p:cNvPr id="10" name="TextBox 9"/>
           <p:cNvSpPr txBox="1"/>
           <p:nvPr/>
         </p:nvSpPr>
@@ -7511,7 +9642,7 @@
       </p:sp>
       <p:sp>
         <p:nvSpPr>
-          <p:cNvPr id="9" name="Rectangle 8"/>
+          <p:cNvPr id="11" name="Rectangle 10"/>
           <p:cNvSpPr/>
           <p:nvPr/>
         </p:nvSpPr>
@@ -7554,14 +9685,14 @@
       </p:sp>
       <p:sp>
         <p:nvSpPr>
-          <p:cNvPr id="10" name="Rounded Rectangle 9"/>
+          <p:cNvPr id="12" name="Rounded Rectangle 11"/>
           <p:cNvSpPr/>
           <p:nvPr/>
         </p:nvSpPr>
         <p:spPr>
           <a:xfrm>
             <a:off x="1295704" y="1645920"/>
-            <a:ext cx="9601200" cy="1645920"/>
+            <a:ext cx="9601200" cy="1545336"/>
           </a:xfrm>
           <a:prstGeom prst="roundRect">
             <a:avLst/>
@@ -7599,14 +9730,14 @@
       </p:sp>
       <p:sp>
         <p:nvSpPr>
-          <p:cNvPr id="11" name="Oval 10"/>
+          <p:cNvPr id="13" name="Oval 12"/>
           <p:cNvSpPr/>
           <p:nvPr/>
         </p:nvSpPr>
         <p:spPr>
           <a:xfrm>
             <a:off x="2255824" y="1828800"/>
-            <a:ext cx="384048" cy="384048"/>
+            <a:ext cx="347472" cy="347472"/>
           </a:xfrm>
           <a:prstGeom prst="ellipse">
             <a:avLst/>
@@ -7642,14 +9773,14 @@
       </p:sp>
       <p:sp>
         <p:nvSpPr>
-          <p:cNvPr id="12" name="TextBox 11"/>
+          <p:cNvPr id="14" name="TextBox 13"/>
           <p:cNvSpPr txBox="1"/>
           <p:nvPr/>
         </p:nvSpPr>
         <p:spPr>
           <a:xfrm>
             <a:off x="2255824" y="1847088"/>
-            <a:ext cx="384048" cy="365760"/>
+            <a:ext cx="347472" cy="329184"/>
           </a:xfrm>
           <a:prstGeom prst="rect">
             <a:avLst/>
@@ -7668,7 +9799,7 @@
               </a:spcAft>
             </a:pPr>
             <a:r>
-              <a:rPr sz="1600" b="1">
+              <a:rPr sz="1400" b="1">
                 <a:solidFill>
                   <a:srgbClr val="FFFFFF"/>
                 </a:solidFill>
@@ -7681,14 +9812,14 @@
       </p:sp>
       <p:sp>
         <p:nvSpPr>
-          <p:cNvPr id="13" name="TextBox 12"/>
+          <p:cNvPr id="15" name="TextBox 14"/>
           <p:cNvSpPr txBox="1"/>
           <p:nvPr/>
         </p:nvSpPr>
         <p:spPr>
           <a:xfrm>
-            <a:off x="2758744" y="1810512"/>
-            <a:ext cx="7772400" cy="502920"/>
+            <a:off x="2713024" y="1810512"/>
+            <a:ext cx="7863840" cy="457200"/>
           </a:xfrm>
           <a:prstGeom prst="rect">
             <a:avLst/>
@@ -7713,21 +9844,21 @@
                 </a:solidFill>
                 <a:latin typeface="Microsoft YaHei"/>
               </a:rPr>
-              <a:t>必做：以「我看见女娲……」开头，写100字画面描述</a:t>
-            </a:r>
-          </a:p>
-        </p:txBody>
-      </p:sp>
-      <p:sp>
-        <p:nvSpPr>
-          <p:cNvPr id="14" name="Oval 13"/>
+              <a:t>必做：以「我看见女娲……」写100字画面</a:t>
+            </a:r>
+          </a:p>
+        </p:txBody>
+      </p:sp>
+      <p:sp>
+        <p:nvSpPr>
+          <p:cNvPr id="16" name="Oval 15"/>
           <p:cNvSpPr/>
           <p:nvPr/>
         </p:nvSpPr>
         <p:spPr>
           <a:xfrm>
             <a:off x="2255824" y="2395728"/>
-            <a:ext cx="384048" cy="384048"/>
+            <a:ext cx="347472" cy="347472"/>
           </a:xfrm>
           <a:prstGeom prst="ellipse">
             <a:avLst/>
@@ -7763,14 +9894,14 @@
       </p:sp>
       <p:sp>
         <p:nvSpPr>
-          <p:cNvPr id="15" name="TextBox 14"/>
+          <p:cNvPr id="17" name="TextBox 16"/>
           <p:cNvSpPr txBox="1"/>
           <p:nvPr/>
         </p:nvSpPr>
         <p:spPr>
           <a:xfrm>
             <a:off x="2255824" y="2414016"/>
-            <a:ext cx="384048" cy="365760"/>
+            <a:ext cx="347472" cy="329184"/>
           </a:xfrm>
           <a:prstGeom prst="rect">
             <a:avLst/>
@@ -7789,7 +9920,7 @@
               </a:spcAft>
             </a:pPr>
             <a:r>
-              <a:rPr sz="1600" b="1">
+              <a:rPr sz="1400" b="1">
                 <a:solidFill>
                   <a:srgbClr val="FFFFFF"/>
                 </a:solidFill>
@@ -7802,14 +9933,14 @@
       </p:sp>
       <p:sp>
         <p:nvSpPr>
-          <p:cNvPr id="16" name="TextBox 15"/>
+          <p:cNvPr id="18" name="TextBox 17"/>
           <p:cNvSpPr txBox="1"/>
           <p:nvPr/>
         </p:nvSpPr>
         <p:spPr>
           <a:xfrm>
-            <a:off x="2758744" y="2377440"/>
-            <a:ext cx="7772400" cy="502920"/>
+            <a:off x="2713024" y="2377440"/>
+            <a:ext cx="7863840" cy="457200"/>
           </a:xfrm>
           <a:prstGeom prst="rect">
             <a:avLst/>

</xml_diff>